<commit_message>
Add new PowerPoint presentation for SIH26207 pitch
</commit_message>
<xml_diff>
--- a/sih-pitch/Avance_SIH26207_Pitch_v2.pptx
+++ b/sih-pitch/Avance_SIH26207_Pitch_v2.pptx
@@ -5,14 +5,14 @@
     <p:sldMasterId id="2147483648" r:id="rId1"/>
   </p:sldMasterIdLst>
   <p:sldIdLst>
-    <p:sldId id="256" r:id="rId7"/>
-    <p:sldId id="257" r:id="rId8"/>
-    <p:sldId id="258" r:id="rId9"/>
-    <p:sldId id="259" r:id="rId10"/>
-    <p:sldId id="260" r:id="rId11"/>
-    <p:sldId id="261" r:id="rId12"/>
+    <p:sldId id="256" r:id="rId2"/>
+    <p:sldId id="257" r:id="rId3"/>
+    <p:sldId id="258" r:id="rId4"/>
+    <p:sldId id="259" r:id="rId5"/>
+    <p:sldId id="260" r:id="rId6"/>
+    <p:sldId id="261" r:id="rId7"/>
   </p:sldIdLst>
-  <p:sldSz cx="12191695" cy="6858000" type="screen4x3"/>
+  <p:sldSz cx="12192000" cy="6858000"/>
   <p:notesSz cx="6858000" cy="9144000"/>
   <p:defaultTextStyle>
     <a:defPPr>
@@ -109,7 +109,29 @@
       </a:defRPr>
     </a:lvl9pPr>
   </p:defaultTextStyle>
+  <p:extLst>
+    <p:ext uri="{EFAFB233-063F-42B5-8137-9DF3F51BA10A}">
+      <p15:sldGuideLst xmlns:p15="http://schemas.microsoft.com/office/powerpoint/2012/main">
+        <p15:guide id="1" orient="horz" pos="2160">
+          <p15:clr>
+            <a:srgbClr val="A4A3A4"/>
+          </p15:clr>
+        </p15:guide>
+        <p15:guide id="2" pos="2880">
+          <p15:clr>
+            <a:srgbClr val="A4A3A4"/>
+          </p15:clr>
+        </p15:guide>
+      </p15:sldGuideLst>
+    </p:ext>
+  </p:extLst>
 </p:presentation>
+</file>
+
+<file path=ppt/authors.xml><?xml version="1.0" encoding="utf-8"?>
+<p188:authorLst xmlns:a="http://schemas.openxmlformats.org/drawingml/2006/main" xmlns:r="http://schemas.openxmlformats.org/officeDocument/2006/relationships" xmlns:p188="http://schemas.microsoft.com/office/powerpoint/2018/8/main">
+  <p188:author id="{E9751F2F-10D0-08EA-1EEE-8B5B10956549}" name="Anirudh K N" initials="AK" userId="1d65839a870f9912" providerId="Windows Live"/>
+</p188:authorLst>
 </file>
 
 <file path=ppt/slideLayouts/slideLayout1.xml><?xml version="1.0" encoding="utf-8"?>
@@ -150,10 +172,9 @@
           <a:lstStyle/>
           <a:p>
             <a:r>
-              <a:rPr lang="en-US" smtClean="0"/>
+              <a:rPr lang="en-US"/>
               <a:t>Click to edit Master title style</a:t>
             </a:r>
-            <a:endParaRPr lang="en-US"/>
           </a:p>
         </p:txBody>
       </p:sp>
@@ -269,10 +290,9 @@
           </a:lstStyle>
           <a:p>
             <a:r>
-              <a:rPr lang="en-US" smtClean="0"/>
+              <a:rPr lang="en-US"/>
               <a:t>Click to edit Master subtitle style</a:t>
             </a:r>
-            <a:endParaRPr lang="en-US"/>
           </a:p>
         </p:txBody>
       </p:sp>
@@ -293,7 +313,7 @@
           <a:p>
             <a:fld id="{5BCAD085-E8A6-8845-BD4E-CB4CCA059FC4}" type="datetimeFigureOut">
               <a:rPr lang="en-US" smtClean="0"/>
-              <a:t>1/27/13</a:t>
+              <a:t>9/13/2026</a:t>
             </a:fld>
             <a:endParaRPr lang="en-US"/>
           </a:p>
@@ -387,10 +407,9 @@
           <a:lstStyle/>
           <a:p>
             <a:r>
-              <a:rPr lang="en-US" smtClean="0"/>
+              <a:rPr lang="en-US"/>
               <a:t>Click to edit Master title style</a:t>
             </a:r>
-            <a:endParaRPr lang="en-US"/>
           </a:p>
         </p:txBody>
       </p:sp>
@@ -411,38 +430,37 @@
           <a:p>
             <a:pPr lvl="0"/>
             <a:r>
-              <a:rPr lang="en-US" smtClean="0"/>
+              <a:rPr lang="en-US"/>
               <a:t>Click to edit Master text styles</a:t>
             </a:r>
           </a:p>
           <a:p>
             <a:pPr lvl="1"/>
             <a:r>
-              <a:rPr lang="en-US" smtClean="0"/>
+              <a:rPr lang="en-US"/>
               <a:t>Second level</a:t>
             </a:r>
           </a:p>
           <a:p>
             <a:pPr lvl="2"/>
             <a:r>
-              <a:rPr lang="en-US" smtClean="0"/>
+              <a:rPr lang="en-US"/>
               <a:t>Third level</a:t>
             </a:r>
           </a:p>
           <a:p>
             <a:pPr lvl="3"/>
             <a:r>
-              <a:rPr lang="en-US" smtClean="0"/>
+              <a:rPr lang="en-US"/>
               <a:t>Fourth level</a:t>
             </a:r>
           </a:p>
           <a:p>
             <a:pPr lvl="4"/>
             <a:r>
-              <a:rPr lang="en-US" smtClean="0"/>
+              <a:rPr lang="en-US"/>
               <a:t>Fifth level</a:t>
             </a:r>
-            <a:endParaRPr lang="en-US"/>
           </a:p>
         </p:txBody>
       </p:sp>
@@ -463,7 +481,7 @@
           <a:p>
             <a:fld id="{5BCAD085-E8A6-8845-BD4E-CB4CCA059FC4}" type="datetimeFigureOut">
               <a:rPr lang="en-US" smtClean="0"/>
-              <a:t>1/27/13</a:t>
+              <a:t>9/13/2026</a:t>
             </a:fld>
             <a:endParaRPr lang="en-US"/>
           </a:p>
@@ -562,10 +580,9 @@
           <a:lstStyle/>
           <a:p>
             <a:r>
-              <a:rPr lang="en-US" smtClean="0"/>
+              <a:rPr lang="en-US"/>
               <a:t>Click to edit Master title style</a:t>
             </a:r>
-            <a:endParaRPr lang="en-US"/>
           </a:p>
         </p:txBody>
       </p:sp>
@@ -591,38 +608,37 @@
           <a:p>
             <a:pPr lvl="0"/>
             <a:r>
-              <a:rPr lang="en-US" smtClean="0"/>
+              <a:rPr lang="en-US"/>
               <a:t>Click to edit Master text styles</a:t>
             </a:r>
           </a:p>
           <a:p>
             <a:pPr lvl="1"/>
             <a:r>
-              <a:rPr lang="en-US" smtClean="0"/>
+              <a:rPr lang="en-US"/>
               <a:t>Second level</a:t>
             </a:r>
           </a:p>
           <a:p>
             <a:pPr lvl="2"/>
             <a:r>
-              <a:rPr lang="en-US" smtClean="0"/>
+              <a:rPr lang="en-US"/>
               <a:t>Third level</a:t>
             </a:r>
           </a:p>
           <a:p>
             <a:pPr lvl="3"/>
             <a:r>
-              <a:rPr lang="en-US" smtClean="0"/>
+              <a:rPr lang="en-US"/>
               <a:t>Fourth level</a:t>
             </a:r>
           </a:p>
           <a:p>
             <a:pPr lvl="4"/>
             <a:r>
-              <a:rPr lang="en-US" smtClean="0"/>
+              <a:rPr lang="en-US"/>
               <a:t>Fifth level</a:t>
             </a:r>
-            <a:endParaRPr lang="en-US"/>
           </a:p>
         </p:txBody>
       </p:sp>
@@ -643,7 +659,7 @@
           <a:p>
             <a:fld id="{5BCAD085-E8A6-8845-BD4E-CB4CCA059FC4}" type="datetimeFigureOut">
               <a:rPr lang="en-US" smtClean="0"/>
-              <a:t>1/27/13</a:t>
+              <a:t>9/13/2026</a:t>
             </a:fld>
             <a:endParaRPr lang="en-US"/>
           </a:p>
@@ -737,10 +753,9 @@
           <a:lstStyle/>
           <a:p>
             <a:r>
-              <a:rPr lang="en-US" smtClean="0"/>
+              <a:rPr lang="en-US"/>
               <a:t>Click to edit Master title style</a:t>
             </a:r>
-            <a:endParaRPr lang="en-US"/>
           </a:p>
         </p:txBody>
       </p:sp>
@@ -761,38 +776,37 @@
           <a:p>
             <a:pPr lvl="0"/>
             <a:r>
-              <a:rPr lang="en-US" smtClean="0"/>
+              <a:rPr lang="en-US"/>
               <a:t>Click to edit Master text styles</a:t>
             </a:r>
           </a:p>
           <a:p>
             <a:pPr lvl="1"/>
             <a:r>
-              <a:rPr lang="en-US" smtClean="0"/>
+              <a:rPr lang="en-US"/>
               <a:t>Second level</a:t>
             </a:r>
           </a:p>
           <a:p>
             <a:pPr lvl="2"/>
             <a:r>
-              <a:rPr lang="en-US" smtClean="0"/>
+              <a:rPr lang="en-US"/>
               <a:t>Third level</a:t>
             </a:r>
           </a:p>
           <a:p>
             <a:pPr lvl="3"/>
             <a:r>
-              <a:rPr lang="en-US" smtClean="0"/>
+              <a:rPr lang="en-US"/>
               <a:t>Fourth level</a:t>
             </a:r>
           </a:p>
           <a:p>
             <a:pPr lvl="4"/>
             <a:r>
-              <a:rPr lang="en-US" smtClean="0"/>
+              <a:rPr lang="en-US"/>
               <a:t>Fifth level</a:t>
             </a:r>
-            <a:endParaRPr lang="en-US"/>
           </a:p>
         </p:txBody>
       </p:sp>
@@ -813,7 +827,7 @@
           <a:p>
             <a:fld id="{5BCAD085-E8A6-8845-BD4E-CB4CCA059FC4}" type="datetimeFigureOut">
               <a:rPr lang="en-US" smtClean="0"/>
-              <a:t>1/27/13</a:t>
+              <a:t>9/13/2026</a:t>
             </a:fld>
             <a:endParaRPr lang="en-US"/>
           </a:p>
@@ -916,10 +930,9 @@
           </a:lstStyle>
           <a:p>
             <a:r>
-              <a:rPr lang="en-US" smtClean="0"/>
+              <a:rPr lang="en-US"/>
               <a:t>Click to edit Master title style</a:t>
             </a:r>
-            <a:endParaRPr lang="en-US"/>
           </a:p>
         </p:txBody>
       </p:sp>
@@ -1036,7 +1049,7 @@
           <a:p>
             <a:pPr lvl="0"/>
             <a:r>
-              <a:rPr lang="en-US" smtClean="0"/>
+              <a:rPr lang="en-US"/>
               <a:t>Click to edit Master text styles</a:t>
             </a:r>
           </a:p>
@@ -1059,7 +1072,7 @@
           <a:p>
             <a:fld id="{5BCAD085-E8A6-8845-BD4E-CB4CCA059FC4}" type="datetimeFigureOut">
               <a:rPr lang="en-US" smtClean="0"/>
-              <a:t>1/27/13</a:t>
+              <a:t>9/13/2026</a:t>
             </a:fld>
             <a:endParaRPr lang="en-US"/>
           </a:p>
@@ -1153,10 +1166,9 @@
           <a:lstStyle/>
           <a:p>
             <a:r>
-              <a:rPr lang="en-US" smtClean="0"/>
+              <a:rPr lang="en-US"/>
               <a:t>Click to edit Master title style</a:t>
             </a:r>
-            <a:endParaRPr lang="en-US"/>
           </a:p>
         </p:txBody>
       </p:sp>
@@ -1210,38 +1222,37 @@
           <a:p>
             <a:pPr lvl="0"/>
             <a:r>
-              <a:rPr lang="en-US" smtClean="0"/>
+              <a:rPr lang="en-US"/>
               <a:t>Click to edit Master text styles</a:t>
             </a:r>
           </a:p>
           <a:p>
             <a:pPr lvl="1"/>
             <a:r>
-              <a:rPr lang="en-US" smtClean="0"/>
+              <a:rPr lang="en-US"/>
               <a:t>Second level</a:t>
             </a:r>
           </a:p>
           <a:p>
             <a:pPr lvl="2"/>
             <a:r>
-              <a:rPr lang="en-US" smtClean="0"/>
+              <a:rPr lang="en-US"/>
               <a:t>Third level</a:t>
             </a:r>
           </a:p>
           <a:p>
             <a:pPr lvl="3"/>
             <a:r>
-              <a:rPr lang="en-US" smtClean="0"/>
+              <a:rPr lang="en-US"/>
               <a:t>Fourth level</a:t>
             </a:r>
           </a:p>
           <a:p>
             <a:pPr lvl="4"/>
             <a:r>
-              <a:rPr lang="en-US" smtClean="0"/>
+              <a:rPr lang="en-US"/>
               <a:t>Fifth level</a:t>
             </a:r>
-            <a:endParaRPr lang="en-US"/>
           </a:p>
         </p:txBody>
       </p:sp>
@@ -1295,38 +1306,37 @@
           <a:p>
             <a:pPr lvl="0"/>
             <a:r>
-              <a:rPr lang="en-US" smtClean="0"/>
+              <a:rPr lang="en-US"/>
               <a:t>Click to edit Master text styles</a:t>
             </a:r>
           </a:p>
           <a:p>
             <a:pPr lvl="1"/>
             <a:r>
-              <a:rPr lang="en-US" smtClean="0"/>
+              <a:rPr lang="en-US"/>
               <a:t>Second level</a:t>
             </a:r>
           </a:p>
           <a:p>
             <a:pPr lvl="2"/>
             <a:r>
-              <a:rPr lang="en-US" smtClean="0"/>
+              <a:rPr lang="en-US"/>
               <a:t>Third level</a:t>
             </a:r>
           </a:p>
           <a:p>
             <a:pPr lvl="3"/>
             <a:r>
-              <a:rPr lang="en-US" smtClean="0"/>
+              <a:rPr lang="en-US"/>
               <a:t>Fourth level</a:t>
             </a:r>
           </a:p>
           <a:p>
             <a:pPr lvl="4"/>
             <a:r>
-              <a:rPr lang="en-US" smtClean="0"/>
+              <a:rPr lang="en-US"/>
               <a:t>Fifth level</a:t>
             </a:r>
-            <a:endParaRPr lang="en-US"/>
           </a:p>
         </p:txBody>
       </p:sp>
@@ -1347,7 +1357,7 @@
           <a:p>
             <a:fld id="{5BCAD085-E8A6-8845-BD4E-CB4CCA059FC4}" type="datetimeFigureOut">
               <a:rPr lang="en-US" smtClean="0"/>
-              <a:t>1/27/13</a:t>
+              <a:t>9/13/2026</a:t>
             </a:fld>
             <a:endParaRPr lang="en-US"/>
           </a:p>
@@ -1445,10 +1455,9 @@
           </a:lstStyle>
           <a:p>
             <a:r>
-              <a:rPr lang="en-US" smtClean="0"/>
+              <a:rPr lang="en-US"/>
               <a:t>Click to edit Master title style</a:t>
             </a:r>
-            <a:endParaRPr lang="en-US"/>
           </a:p>
         </p:txBody>
       </p:sp>
@@ -1511,7 +1520,7 @@
           <a:p>
             <a:pPr lvl="0"/>
             <a:r>
-              <a:rPr lang="en-US" smtClean="0"/>
+              <a:rPr lang="en-US"/>
               <a:t>Click to edit Master text styles</a:t>
             </a:r>
           </a:p>
@@ -1567,38 +1576,37 @@
           <a:p>
             <a:pPr lvl="0"/>
             <a:r>
-              <a:rPr lang="en-US" smtClean="0"/>
+              <a:rPr lang="en-US"/>
               <a:t>Click to edit Master text styles</a:t>
             </a:r>
           </a:p>
           <a:p>
             <a:pPr lvl="1"/>
             <a:r>
-              <a:rPr lang="en-US" smtClean="0"/>
+              <a:rPr lang="en-US"/>
               <a:t>Second level</a:t>
             </a:r>
           </a:p>
           <a:p>
             <a:pPr lvl="2"/>
             <a:r>
-              <a:rPr lang="en-US" smtClean="0"/>
+              <a:rPr lang="en-US"/>
               <a:t>Third level</a:t>
             </a:r>
           </a:p>
           <a:p>
             <a:pPr lvl="3"/>
             <a:r>
-              <a:rPr lang="en-US" smtClean="0"/>
+              <a:rPr lang="en-US"/>
               <a:t>Fourth level</a:t>
             </a:r>
           </a:p>
           <a:p>
             <a:pPr lvl="4"/>
             <a:r>
-              <a:rPr lang="en-US" smtClean="0"/>
+              <a:rPr lang="en-US"/>
               <a:t>Fifth level</a:t>
             </a:r>
-            <a:endParaRPr lang="en-US"/>
           </a:p>
         </p:txBody>
       </p:sp>
@@ -1661,7 +1669,7 @@
           <a:p>
             <a:pPr lvl="0"/>
             <a:r>
-              <a:rPr lang="en-US" smtClean="0"/>
+              <a:rPr lang="en-US"/>
               <a:t>Click to edit Master text styles</a:t>
             </a:r>
           </a:p>
@@ -1717,38 +1725,37 @@
           <a:p>
             <a:pPr lvl="0"/>
             <a:r>
-              <a:rPr lang="en-US" smtClean="0"/>
+              <a:rPr lang="en-US"/>
               <a:t>Click to edit Master text styles</a:t>
             </a:r>
           </a:p>
           <a:p>
             <a:pPr lvl="1"/>
             <a:r>
-              <a:rPr lang="en-US" smtClean="0"/>
+              <a:rPr lang="en-US"/>
               <a:t>Second level</a:t>
             </a:r>
           </a:p>
           <a:p>
             <a:pPr lvl="2"/>
             <a:r>
-              <a:rPr lang="en-US" smtClean="0"/>
+              <a:rPr lang="en-US"/>
               <a:t>Third level</a:t>
             </a:r>
           </a:p>
           <a:p>
             <a:pPr lvl="3"/>
             <a:r>
-              <a:rPr lang="en-US" smtClean="0"/>
+              <a:rPr lang="en-US"/>
               <a:t>Fourth level</a:t>
             </a:r>
           </a:p>
           <a:p>
             <a:pPr lvl="4"/>
             <a:r>
-              <a:rPr lang="en-US" smtClean="0"/>
+              <a:rPr lang="en-US"/>
               <a:t>Fifth level</a:t>
             </a:r>
-            <a:endParaRPr lang="en-US"/>
           </a:p>
         </p:txBody>
       </p:sp>
@@ -1769,7 +1776,7 @@
           <a:p>
             <a:fld id="{5BCAD085-E8A6-8845-BD4E-CB4CCA059FC4}" type="datetimeFigureOut">
               <a:rPr lang="en-US" smtClean="0"/>
-              <a:t>1/27/13</a:t>
+              <a:t>9/13/2026</a:t>
             </a:fld>
             <a:endParaRPr lang="en-US"/>
           </a:p>
@@ -1863,10 +1870,9 @@
           <a:lstStyle/>
           <a:p>
             <a:r>
-              <a:rPr lang="en-US" smtClean="0"/>
+              <a:rPr lang="en-US"/>
               <a:t>Click to edit Master title style</a:t>
             </a:r>
-            <a:endParaRPr lang="en-US"/>
           </a:p>
         </p:txBody>
       </p:sp>
@@ -1887,7 +1893,7 @@
           <a:p>
             <a:fld id="{5BCAD085-E8A6-8845-BD4E-CB4CCA059FC4}" type="datetimeFigureOut">
               <a:rPr lang="en-US" smtClean="0"/>
-              <a:t>1/27/13</a:t>
+              <a:t>9/13/2026</a:t>
             </a:fld>
             <a:endParaRPr lang="en-US"/>
           </a:p>
@@ -1982,7 +1988,7 @@
           <a:p>
             <a:fld id="{5BCAD085-E8A6-8845-BD4E-CB4CCA059FC4}" type="datetimeFigureOut">
               <a:rPr lang="en-US" smtClean="0"/>
-              <a:t>1/27/13</a:t>
+              <a:t>9/13/2026</a:t>
             </a:fld>
             <a:endParaRPr lang="en-US"/>
           </a:p>
@@ -2085,10 +2091,9 @@
           </a:lstStyle>
           <a:p>
             <a:r>
-              <a:rPr lang="en-US" smtClean="0"/>
+              <a:rPr lang="en-US"/>
               <a:t>Click to edit Master title style</a:t>
             </a:r>
-            <a:endParaRPr lang="en-US"/>
           </a:p>
         </p:txBody>
       </p:sp>
@@ -2142,38 +2147,37 @@
           <a:p>
             <a:pPr lvl="0"/>
             <a:r>
-              <a:rPr lang="en-US" smtClean="0"/>
+              <a:rPr lang="en-US"/>
               <a:t>Click to edit Master text styles</a:t>
             </a:r>
           </a:p>
           <a:p>
             <a:pPr lvl="1"/>
             <a:r>
-              <a:rPr lang="en-US" smtClean="0"/>
+              <a:rPr lang="en-US"/>
               <a:t>Second level</a:t>
             </a:r>
           </a:p>
           <a:p>
             <a:pPr lvl="2"/>
             <a:r>
-              <a:rPr lang="en-US" smtClean="0"/>
+              <a:rPr lang="en-US"/>
               <a:t>Third level</a:t>
             </a:r>
           </a:p>
           <a:p>
             <a:pPr lvl="3"/>
             <a:r>
-              <a:rPr lang="en-US" smtClean="0"/>
+              <a:rPr lang="en-US"/>
               <a:t>Fourth level</a:t>
             </a:r>
           </a:p>
           <a:p>
             <a:pPr lvl="4"/>
             <a:r>
-              <a:rPr lang="en-US" smtClean="0"/>
+              <a:rPr lang="en-US"/>
               <a:t>Fifth level</a:t>
             </a:r>
-            <a:endParaRPr lang="en-US"/>
           </a:p>
         </p:txBody>
       </p:sp>
@@ -2236,7 +2240,7 @@
           <a:p>
             <a:pPr lvl="0"/>
             <a:r>
-              <a:rPr lang="en-US" smtClean="0"/>
+              <a:rPr lang="en-US"/>
               <a:t>Click to edit Master text styles</a:t>
             </a:r>
           </a:p>
@@ -2259,7 +2263,7 @@
           <a:p>
             <a:fld id="{5BCAD085-E8A6-8845-BD4E-CB4CCA059FC4}" type="datetimeFigureOut">
               <a:rPr lang="en-US" smtClean="0"/>
-              <a:t>1/27/13</a:t>
+              <a:t>9/13/2026</a:t>
             </a:fld>
             <a:endParaRPr lang="en-US"/>
           </a:p>
@@ -2362,10 +2366,9 @@
           </a:lstStyle>
           <a:p>
             <a:r>
-              <a:rPr lang="en-US" smtClean="0"/>
+              <a:rPr lang="en-US"/>
               <a:t>Click to edit Master title style</a:t>
             </a:r>
-            <a:endParaRPr lang="en-US"/>
           </a:p>
         </p:txBody>
       </p:sp>
@@ -2489,7 +2492,7 @@
           <a:p>
             <a:pPr lvl="0"/>
             <a:r>
-              <a:rPr lang="en-US" smtClean="0"/>
+              <a:rPr lang="en-US"/>
               <a:t>Click to edit Master text styles</a:t>
             </a:r>
           </a:p>
@@ -2512,7 +2515,7 @@
           <a:p>
             <a:fld id="{5BCAD085-E8A6-8845-BD4E-CB4CCA059FC4}" type="datetimeFigureOut">
               <a:rPr lang="en-US" smtClean="0"/>
-              <a:t>1/27/13</a:t>
+              <a:t>9/13/2026</a:t>
             </a:fld>
             <a:endParaRPr lang="en-US"/>
           </a:p>
@@ -2624,10 +2627,9 @@
           <a:lstStyle/>
           <a:p>
             <a:r>
-              <a:rPr lang="en-US" smtClean="0"/>
+              <a:rPr lang="en-US"/>
               <a:t>Click to edit Master title style</a:t>
             </a:r>
-            <a:endParaRPr lang="en-US"/>
           </a:p>
         </p:txBody>
       </p:sp>
@@ -2658,38 +2660,37 @@
           <a:p>
             <a:pPr lvl="0"/>
             <a:r>
-              <a:rPr lang="en-US" smtClean="0"/>
+              <a:rPr lang="en-US"/>
               <a:t>Click to edit Master text styles</a:t>
             </a:r>
           </a:p>
           <a:p>
             <a:pPr lvl="1"/>
             <a:r>
-              <a:rPr lang="en-US" smtClean="0"/>
+              <a:rPr lang="en-US"/>
               <a:t>Second level</a:t>
             </a:r>
           </a:p>
           <a:p>
             <a:pPr lvl="2"/>
             <a:r>
-              <a:rPr lang="en-US" smtClean="0"/>
+              <a:rPr lang="en-US"/>
               <a:t>Third level</a:t>
             </a:r>
           </a:p>
           <a:p>
             <a:pPr lvl="3"/>
             <a:r>
-              <a:rPr lang="en-US" smtClean="0"/>
+              <a:rPr lang="en-US"/>
               <a:t>Fourth level</a:t>
             </a:r>
           </a:p>
           <a:p>
             <a:pPr lvl="4"/>
             <a:r>
-              <a:rPr lang="en-US" smtClean="0"/>
+              <a:rPr lang="en-US"/>
               <a:t>Fifth level</a:t>
             </a:r>
-            <a:endParaRPr lang="en-US"/>
           </a:p>
         </p:txBody>
       </p:sp>
@@ -2728,7 +2729,7 @@
           <a:p>
             <a:fld id="{5BCAD085-E8A6-8845-BD4E-CB4CCA059FC4}" type="datetimeFigureOut">
               <a:rPr lang="en-US" smtClean="0"/>
-              <a:t>1/27/13</a:t>
+              <a:t>9/13/2026</a:t>
             </a:fld>
             <a:endParaRPr lang="en-US"/>
           </a:p>
@@ -3087,7 +3088,7 @@
 </file>
 
 <file path=ppt/slides/slide1.xml><?xml version="1.0" encoding="utf-8"?>
-<p:sld xmlns:a="http://schemas.openxmlformats.org/drawingml/2006/main" xmlns:p="http://schemas.openxmlformats.org/presentationml/2006/main" xmlns:r="http://schemas.openxmlformats.org/officeDocument/2006/relationships">
+<p:sld xmlns:a="http://schemas.openxmlformats.org/drawingml/2006/main" xmlns:r="http://schemas.openxmlformats.org/officeDocument/2006/relationships" xmlns:p="http://schemas.openxmlformats.org/presentationml/2006/main">
   <p:cSld>
     <p:spTree>
       <p:nvGrpSpPr>
@@ -3095,7 +3096,14 @@
         <p:cNvGrpSpPr/>
         <p:nvPr/>
       </p:nvGrpSpPr>
-      <p:grpSpPr/>
+      <p:grpSpPr>
+        <a:xfrm>
+          <a:off x="0" y="0"/>
+          <a:ext cx="0" cy="0"/>
+          <a:chOff x="0" y="0"/>
+          <a:chExt cx="0" cy="0"/>
+        </a:xfrm>
+      </p:grpSpPr>
       <p:sp>
         <p:nvSpPr>
           <p:cNvPr id="2" name="BGPlate"/>
@@ -3104,7 +3112,7 @@
         </p:nvSpPr>
         <p:spPr>
           <a:xfrm>
-            <a:off x="-45720" y="-45720"/>
+            <a:off x="446650" y="1143000"/>
             <a:ext cx="12280392" cy="6949440"/>
           </a:xfrm>
           <a:prstGeom prst="rect">
@@ -3119,7 +3127,7 @@
                 <a:srgbClr val="3B1F7A"/>
               </a:gs>
             </a:gsLst>
-            <a:lin scaled="0" ang="14100000"/>
+            <a:lin ang="14100000" scaled="0"/>
           </a:gradFill>
           <a:ln>
             <a:noFill/>
@@ -3145,6 +3153,7 @@
           <a:lstStyle/>
           <a:p>
             <a:pPr algn="ctr"/>
+            <a:endParaRPr/>
           </a:p>
         </p:txBody>
       </p:sp>
@@ -3191,6 +3200,7 @@
           <a:lstStyle/>
           <a:p>
             <a:pPr algn="ctr"/>
+            <a:endParaRPr/>
           </a:p>
         </p:txBody>
       </p:sp>
@@ -3237,6 +3247,7 @@
           <a:lstStyle/>
           <a:p>
             <a:pPr algn="ctr"/>
+            <a:endParaRPr/>
           </a:p>
         </p:txBody>
       </p:sp>
@@ -3283,6 +3294,7 @@
           <a:lstStyle/>
           <a:p>
             <a:pPr algn="ctr"/>
+            <a:endParaRPr/>
           </a:p>
         </p:txBody>
       </p:sp>
@@ -3329,6 +3341,7 @@
           <a:lstStyle/>
           <a:p>
             <a:pPr algn="ctr"/>
+            <a:endParaRPr/>
           </a:p>
         </p:txBody>
       </p:sp>
@@ -3375,6 +3388,7 @@
           <a:lstStyle/>
           <a:p>
             <a:pPr algn="ctr"/>
+            <a:endParaRPr/>
           </a:p>
         </p:txBody>
       </p:sp>
@@ -3421,6 +3435,7 @@
           <a:lstStyle/>
           <a:p>
             <a:pPr algn="ctr"/>
+            <a:endParaRPr/>
           </a:p>
         </p:txBody>
       </p:sp>
@@ -3467,6 +3482,7 @@
           <a:lstStyle/>
           <a:p>
             <a:pPr algn="ctr"/>
+            <a:endParaRPr/>
           </a:p>
         </p:txBody>
       </p:sp>
@@ -3513,6 +3529,7 @@
           <a:lstStyle/>
           <a:p>
             <a:pPr algn="ctr"/>
+            <a:endParaRPr/>
           </a:p>
         </p:txBody>
       </p:sp>
@@ -3563,6 +3580,7 @@
           <a:lstStyle/>
           <a:p>
             <a:pPr algn="ctr"/>
+            <a:endParaRPr/>
           </a:p>
         </p:txBody>
       </p:sp>
@@ -3583,7 +3601,7 @@
           <a:noFill/>
         </p:spPr>
         <p:txBody>
-          <a:bodyPr wrap="square" anchor="ctr" lIns="0" rIns="0" tIns="0" bIns="0">
+          <a:bodyPr wrap="square" lIns="0" tIns="0" rIns="0" bIns="0" anchor="ctr">
             <a:spAutoFit/>
           </a:bodyPr>
           <a:lstStyle/>
@@ -3618,7 +3636,7 @@
           <a:noFill/>
         </p:spPr>
         <p:txBody>
-          <a:bodyPr wrap="square" anchor="t" lIns="0" rIns="0" tIns="0" bIns="0">
+          <a:bodyPr wrap="square" lIns="0" tIns="0" rIns="0" bIns="0" anchor="t">
             <a:spAutoFit/>
           </a:bodyPr>
           <a:lstStyle/>
@@ -3655,14 +3673,14 @@
           <a:noFill/>
         </p:spPr>
         <p:txBody>
-          <a:bodyPr wrap="square" anchor="t" lIns="0" rIns="0" tIns="0" bIns="0">
+          <a:bodyPr wrap="square" lIns="0" tIns="0" rIns="0" bIns="0" anchor="t">
             <a:spAutoFit/>
           </a:bodyPr>
           <a:lstStyle/>
           <a:p>
             <a:pPr algn="l"/>
             <a:r>
-              <a:rPr sz="9200" b="1" i="0">
+              <a:rPr sz="9200" b="1" i="0" dirty="0">
                 <a:solidFill>
                   <a:srgbClr val="FFFFFF"/>
                 </a:solidFill>
@@ -3690,7 +3708,7 @@
           <a:noFill/>
         </p:spPr>
         <p:txBody>
-          <a:bodyPr wrap="square" anchor="t" lIns="0" rIns="0" tIns="0" bIns="0">
+          <a:bodyPr wrap="square" lIns="0" tIns="0" rIns="0" bIns="0" anchor="t">
             <a:spAutoFit/>
           </a:bodyPr>
           <a:lstStyle/>
@@ -3725,14 +3743,14 @@
           <a:noFill/>
         </p:spPr>
         <p:txBody>
-          <a:bodyPr wrap="square" anchor="t" lIns="0" rIns="0" tIns="0" bIns="0">
+          <a:bodyPr wrap="square" lIns="0" tIns="0" rIns="0" bIns="0" anchor="t">
             <a:spAutoFit/>
           </a:bodyPr>
           <a:lstStyle/>
           <a:p>
             <a:pPr algn="l"/>
             <a:r>
-              <a:rPr sz="1350" b="0" i="1">
+              <a:rPr sz="1350" b="0" i="1" dirty="0">
                 <a:solidFill>
                   <a:srgbClr val="FFFFFF">
                     <a:alpha val="62000"/>
@@ -3788,6 +3806,7 @@
           <a:lstStyle/>
           <a:p>
             <a:pPr algn="ctr"/>
+            <a:endParaRPr/>
           </a:p>
         </p:txBody>
       </p:sp>
@@ -3808,7 +3827,7 @@
           <a:noFill/>
         </p:spPr>
         <p:txBody>
-          <a:bodyPr wrap="square" anchor="t" lIns="0" rIns="0" tIns="0" bIns="0">
+          <a:bodyPr wrap="square" lIns="0" tIns="0" rIns="0" bIns="0" anchor="t">
             <a:spAutoFit/>
           </a:bodyPr>
           <a:lstStyle/>
@@ -3835,7 +3854,7 @@
         <p:spPr>
           <a:xfrm>
             <a:off x="640080" y="5623560"/>
-            <a:ext cx="2606040" cy="320040"/>
+            <a:ext cx="2606040" cy="200055"/>
           </a:xfrm>
           <a:prstGeom prst="rect">
             <a:avLst/>
@@ -3843,14 +3862,14 @@
           <a:noFill/>
         </p:spPr>
         <p:txBody>
-          <a:bodyPr wrap="square" anchor="t" lIns="0" rIns="0" tIns="0" bIns="0">
+          <a:bodyPr wrap="square" lIns="0" tIns="0" rIns="0" bIns="0" anchor="t">
             <a:spAutoFit/>
           </a:bodyPr>
           <a:lstStyle/>
           <a:p>
             <a:pPr algn="l"/>
             <a:r>
-              <a:rPr sz="1300" b="0" i="0">
+              <a:rPr lang="en-IN" sz="1300" b="0" i="0" dirty="0">
                 <a:solidFill>
                   <a:srgbClr val="FFFFFF">
                     <a:alpha val="90000"/>
@@ -3858,8 +3877,16 @@
                 </a:solidFill>
                 <a:latin typeface="Segoe UI"/>
               </a:rPr>
-              <a:t>[ Your Team Name ]</a:t>
-            </a:r>
+              <a:t>Avance</a:t>
+            </a:r>
+            <a:endParaRPr sz="1300" b="0" i="0" dirty="0">
+              <a:solidFill>
+                <a:srgbClr val="FFFFFF">
+                  <a:alpha val="90000"/>
+                </a:srgbClr>
+              </a:solidFill>
+              <a:latin typeface="Segoe UI"/>
+            </a:endParaRPr>
           </a:p>
         </p:txBody>
       </p:sp>
@@ -3880,7 +3907,7 @@
           <a:noFill/>
         </p:spPr>
         <p:txBody>
-          <a:bodyPr wrap="square" anchor="t" lIns="0" rIns="0" tIns="0" bIns="0">
+          <a:bodyPr wrap="square" lIns="0" tIns="0" rIns="0" bIns="0" anchor="t">
             <a:spAutoFit/>
           </a:bodyPr>
           <a:lstStyle/>
@@ -3907,7 +3934,7 @@
         <p:spPr>
           <a:xfrm>
             <a:off x="3337560" y="5623560"/>
-            <a:ext cx="2606040" cy="320040"/>
+            <a:ext cx="2606040" cy="400110"/>
           </a:xfrm>
           <a:prstGeom prst="rect">
             <a:avLst/>
@@ -3915,14 +3942,14 @@
           <a:noFill/>
         </p:spPr>
         <p:txBody>
-          <a:bodyPr wrap="square" anchor="t" lIns="0" rIns="0" tIns="0" bIns="0">
+          <a:bodyPr wrap="square" lIns="0" tIns="0" rIns="0" bIns="0" anchor="t">
             <a:spAutoFit/>
           </a:bodyPr>
           <a:lstStyle/>
           <a:p>
             <a:pPr algn="l"/>
             <a:r>
-              <a:rPr sz="1300" b="0" i="0">
+              <a:rPr lang="en-IN" sz="1300" dirty="0">
                 <a:solidFill>
                   <a:srgbClr val="FFFFFF">
                     <a:alpha val="90000"/>
@@ -3930,71 +3957,13 @@
                 </a:solidFill>
                 <a:latin typeface="Segoe UI"/>
               </a:rPr>
-              <a:t>[ Leader Name ]</a:t>
-            </a:r>
-          </a:p>
-        </p:txBody>
-      </p:sp>
-      <p:sp>
-        <p:nvSpPr>
-          <p:cNvPr id="22" name="TextBox 21"/>
-          <p:cNvSpPr txBox="1"/>
-          <p:nvPr/>
-        </p:nvSpPr>
-        <p:spPr>
-          <a:xfrm>
-            <a:off x="6035040" y="5349240"/>
-            <a:ext cx="2606040" cy="274320"/>
-          </a:xfrm>
-          <a:prstGeom prst="rect">
-            <a:avLst/>
-          </a:prstGeom>
-          <a:noFill/>
-        </p:spPr>
-        <p:txBody>
-          <a:bodyPr wrap="square" anchor="t" lIns="0" rIns="0" tIns="0" bIns="0">
-            <a:spAutoFit/>
-          </a:bodyPr>
-          <a:lstStyle/>
+              <a:t>K N Anirudh</a:t>
+            </a:r>
+          </a:p>
           <a:p>
             <a:pPr algn="l"/>
             <a:r>
-              <a:rPr sz="1000" b="1" i="0" spc="160">
-                <a:solidFill>
-                  <a:srgbClr val="B497CF"/>
-                </a:solidFill>
-                <a:latin typeface="Consolas"/>
-              </a:rPr>
-              <a:t>INSTITUTION</a:t>
-            </a:r>
-          </a:p>
-        </p:txBody>
-      </p:sp>
-      <p:sp>
-        <p:nvSpPr>
-          <p:cNvPr id="23" name="TextBox 22"/>
-          <p:cNvSpPr txBox="1"/>
-          <p:nvPr/>
-        </p:nvSpPr>
-        <p:spPr>
-          <a:xfrm>
-            <a:off x="6035040" y="5623560"/>
-            <a:ext cx="2606040" cy="320040"/>
-          </a:xfrm>
-          <a:prstGeom prst="rect">
-            <a:avLst/>
-          </a:prstGeom>
-          <a:noFill/>
-        </p:spPr>
-        <p:txBody>
-          <a:bodyPr wrap="square" anchor="t" lIns="0" rIns="0" tIns="0" bIns="0">
-            <a:spAutoFit/>
-          </a:bodyPr>
-          <a:lstStyle/>
-          <a:p>
-            <a:pPr algn="l"/>
-            <a:r>
-              <a:rPr sz="1300" b="0" i="0">
+              <a:rPr lang="en-IN" sz="1300" b="0" i="0" dirty="0">
                 <a:solidFill>
                   <a:srgbClr val="FFFFFF">
                     <a:alpha val="90000"/>
@@ -4002,71 +3971,10 @@
                 </a:solidFill>
                 <a:latin typeface="Segoe UI"/>
               </a:rPr>
-              <a:t>[ Institution ]</a:t>
-            </a:r>
-          </a:p>
-        </p:txBody>
-      </p:sp>
-      <p:sp>
-        <p:nvSpPr>
-          <p:cNvPr id="24" name="TextBox 23"/>
-          <p:cNvSpPr txBox="1"/>
-          <p:nvPr/>
-        </p:nvSpPr>
-        <p:spPr>
-          <a:xfrm>
-            <a:off x="8732520" y="5349240"/>
-            <a:ext cx="2606040" cy="274320"/>
-          </a:xfrm>
-          <a:prstGeom prst="rect">
-            <a:avLst/>
-          </a:prstGeom>
-          <a:noFill/>
-        </p:spPr>
-        <p:txBody>
-          <a:bodyPr wrap="square" anchor="t" lIns="0" rIns="0" tIns="0" bIns="0">
-            <a:spAutoFit/>
-          </a:bodyPr>
-          <a:lstStyle/>
-          <a:p>
-            <a:pPr algn="l"/>
-            <a:r>
-              <a:rPr sz="1000" b="1" i="0" spc="160">
-                <a:solidFill>
-                  <a:srgbClr val="B497CF"/>
-                </a:solidFill>
-                <a:latin typeface="Consolas"/>
-              </a:rPr>
-              <a:t>MENTOR</a:t>
-            </a:r>
-          </a:p>
-        </p:txBody>
-      </p:sp>
-      <p:sp>
-        <p:nvSpPr>
-          <p:cNvPr id="25" name="TextBox 24"/>
-          <p:cNvSpPr txBox="1"/>
-          <p:nvPr/>
-        </p:nvSpPr>
-        <p:spPr>
-          <a:xfrm>
-            <a:off x="8732520" y="5623560"/>
-            <a:ext cx="2606040" cy="320040"/>
-          </a:xfrm>
-          <a:prstGeom prst="rect">
-            <a:avLst/>
-          </a:prstGeom>
-          <a:noFill/>
-        </p:spPr>
-        <p:txBody>
-          <a:bodyPr wrap="square" anchor="t" lIns="0" rIns="0" tIns="0" bIns="0">
-            <a:spAutoFit/>
-          </a:bodyPr>
-          <a:lstStyle/>
-          <a:p>
-            <a:pPr algn="l"/>
-            <a:r>
-              <a:rPr sz="1300" b="0" i="0">
+              <a:t>(Backend, Frontend, ppt)</a:t>
+            </a:r>
+            <a:r>
+              <a:rPr sz="1300" b="0" i="0" dirty="0">
                 <a:solidFill>
                   <a:srgbClr val="FFFFFF">
                     <a:alpha val="90000"/>
@@ -4074,24 +3982,183 @@
                 </a:solidFill>
                 <a:latin typeface="Segoe UI"/>
               </a:rPr>
-              <a:t>[ Mentor Name ]</a:t>
-            </a:r>
+              <a:t> </a:t>
+            </a:r>
+          </a:p>
+        </p:txBody>
+      </p:sp>
+      <p:sp>
+        <p:nvSpPr>
+          <p:cNvPr id="22" name="TextBox 21"/>
+          <p:cNvSpPr txBox="1"/>
+          <p:nvPr/>
+        </p:nvSpPr>
+        <p:spPr>
+          <a:xfrm>
+            <a:off x="5943600" y="5673716"/>
+            <a:ext cx="5370576" cy="923330"/>
+          </a:xfrm>
+          <a:prstGeom prst="rect">
+            <a:avLst/>
+          </a:prstGeom>
+          <a:noFill/>
+        </p:spPr>
+        <p:txBody>
+          <a:bodyPr wrap="square" lIns="0" tIns="0" rIns="0" bIns="0" anchor="t">
+            <a:spAutoFit/>
+          </a:bodyPr>
+          <a:lstStyle/>
+          <a:p>
+            <a:pPr algn="l"/>
+            <a:r>
+              <a:rPr lang="en-IN" sz="1200" b="1" i="0" spc="160" dirty="0">
+                <a:solidFill>
+                  <a:schemeClr val="bg1">
+                    <a:lumMod val="95000"/>
+                  </a:schemeClr>
+                </a:solidFill>
+                <a:latin typeface="Consolas"/>
+              </a:rPr>
+              <a:t>1.Devyansh ( Presentation)</a:t>
+            </a:r>
+          </a:p>
+          <a:p>
+            <a:pPr algn="l"/>
+            <a:r>
+              <a:rPr lang="en-IN" sz="1200" b="1" spc="160" dirty="0">
+                <a:solidFill>
+                  <a:schemeClr val="bg1">
+                    <a:lumMod val="95000"/>
+                  </a:schemeClr>
+                </a:solidFill>
+                <a:latin typeface="Consolas"/>
+              </a:rPr>
+              <a:t>2. Akash (Presentation)</a:t>
+            </a:r>
+          </a:p>
+          <a:p>
+            <a:pPr algn="l"/>
+            <a:r>
+              <a:rPr lang="en-IN" sz="1200" b="1" i="0" spc="160" dirty="0">
+                <a:solidFill>
+                  <a:schemeClr val="bg1">
+                    <a:lumMod val="95000"/>
+                  </a:schemeClr>
+                </a:solidFill>
+                <a:latin typeface="Consolas"/>
+              </a:rPr>
+              <a:t>3.Keshav (Analysis of bugs)</a:t>
+            </a:r>
+          </a:p>
+          <a:p>
+            <a:pPr algn="l"/>
+            <a:r>
+              <a:rPr lang="en-IN" sz="1200" b="1" spc="160" dirty="0">
+                <a:solidFill>
+                  <a:schemeClr val="bg1">
+                    <a:lumMod val="95000"/>
+                  </a:schemeClr>
+                </a:solidFill>
+                <a:latin typeface="Consolas"/>
+              </a:rPr>
+              <a:t>4. Vedant(Research)</a:t>
+            </a:r>
+          </a:p>
+          <a:p>
+            <a:pPr algn="l"/>
+            <a:r>
+              <a:rPr lang="en-IN" sz="1200" b="1" i="0" spc="160" dirty="0">
+                <a:solidFill>
+                  <a:schemeClr val="bg1">
+                    <a:lumMod val="95000"/>
+                  </a:schemeClr>
+                </a:solidFill>
+                <a:latin typeface="Consolas"/>
+              </a:rPr>
+              <a:t>5. Divya</a:t>
+            </a:r>
+            <a:r>
+              <a:rPr lang="en-IN" sz="1200" b="1" spc="160" dirty="0">
+                <a:solidFill>
+                  <a:schemeClr val="bg1">
+                    <a:lumMod val="95000"/>
+                  </a:schemeClr>
+                </a:solidFill>
+                <a:latin typeface="Consolas"/>
+              </a:rPr>
+              <a:t> Shree N (UI ,Planning, ppt) </a:t>
+            </a:r>
+            <a:endParaRPr sz="1200" b="1" i="0" spc="160" dirty="0">
+              <a:solidFill>
+                <a:schemeClr val="bg1">
+                  <a:lumMod val="95000"/>
+                </a:schemeClr>
+              </a:solidFill>
+              <a:latin typeface="Consolas"/>
+            </a:endParaRPr>
+          </a:p>
+        </p:txBody>
+      </p:sp>
+      <p:sp>
+        <p:nvSpPr>
+          <p:cNvPr id="23" name="TextBox 22"/>
+          <p:cNvSpPr txBox="1"/>
+          <p:nvPr/>
+        </p:nvSpPr>
+        <p:spPr>
+          <a:xfrm>
+            <a:off x="6151168" y="5270548"/>
+            <a:ext cx="2992832" cy="200055"/>
+          </a:xfrm>
+          <a:prstGeom prst="rect">
+            <a:avLst/>
+          </a:prstGeom>
+          <a:noFill/>
+        </p:spPr>
+        <p:txBody>
+          <a:bodyPr wrap="square" lIns="0" tIns="0" rIns="0" bIns="0" anchor="t">
+            <a:spAutoFit/>
+          </a:bodyPr>
+          <a:lstStyle/>
+          <a:p>
+            <a:pPr algn="l"/>
+            <a:r>
+              <a:rPr lang="en-IN" sz="1300" b="0" i="0" dirty="0">
+                <a:solidFill>
+                  <a:schemeClr val="accent2">
+                    <a:lumMod val="75000"/>
+                    <a:alpha val="90000"/>
+                  </a:schemeClr>
+                </a:solidFill>
+                <a:latin typeface="Segoe UI"/>
+              </a:rPr>
+              <a:t>  Team Members</a:t>
+            </a:r>
+            <a:endParaRPr sz="1300" b="0" i="0" dirty="0">
+              <a:solidFill>
+                <a:schemeClr val="accent2">
+                  <a:lumMod val="75000"/>
+                  <a:alpha val="90000"/>
+                </a:schemeClr>
+              </a:solidFill>
+              <a:latin typeface="Segoe UI"/>
+            </a:endParaRPr>
           </a:p>
         </p:txBody>
       </p:sp>
     </p:spTree>
   </p:cSld>
-  <p:transition spd="slow">
-    <p:fade thruBlk="0"/>
-  </p:transition>
   <p:clrMapOvr>
     <a:masterClrMapping/>
   </p:clrMapOvr>
+  <p:transition spd="slow">
+    <p:push dir="u"/>
+  </p:transition>
 </p:sld>
 </file>
 
 <file path=ppt/slides/slide2.xml><?xml version="1.0" encoding="utf-8"?>
-<p:sld xmlns:a="http://schemas.openxmlformats.org/drawingml/2006/main" xmlns:p="http://schemas.openxmlformats.org/presentationml/2006/main" xmlns:r="http://schemas.openxmlformats.org/officeDocument/2006/relationships">
+<p:sld xmlns:a="http://schemas.openxmlformats.org/drawingml/2006/main" xmlns:r="http://schemas.openxmlformats.org/officeDocument/2006/relationships" xmlns:p="http://schemas.openxmlformats.org/presentationml/2006/main">
   <p:cSld>
     <p:spTree>
       <p:nvGrpSpPr>
@@ -4099,7 +4166,14 @@
         <p:cNvGrpSpPr/>
         <p:nvPr/>
       </p:nvGrpSpPr>
-      <p:grpSpPr/>
+      <p:grpSpPr>
+        <a:xfrm>
+          <a:off x="0" y="0"/>
+          <a:ext cx="0" cy="0"/>
+          <a:chOff x="0" y="0"/>
+          <a:chExt cx="0" cy="0"/>
+        </a:xfrm>
+      </p:grpSpPr>
       <p:sp>
         <p:nvSpPr>
           <p:cNvPr id="2" name="BGPlate"/>
@@ -4123,7 +4197,7 @@
                 <a:srgbClr val="3B1F7A"/>
               </a:gs>
             </a:gsLst>
-            <a:lin scaled="0" ang="15600000"/>
+            <a:lin ang="15600000" scaled="0"/>
           </a:gradFill>
           <a:ln>
             <a:noFill/>
@@ -4149,6 +4223,7 @@
           <a:lstStyle/>
           <a:p>
             <a:pPr algn="ctr"/>
+            <a:endParaRPr/>
           </a:p>
         </p:txBody>
       </p:sp>
@@ -4195,6 +4270,7 @@
           <a:lstStyle/>
           <a:p>
             <a:pPr algn="ctr"/>
+            <a:endParaRPr/>
           </a:p>
         </p:txBody>
       </p:sp>
@@ -4241,6 +4317,7 @@
           <a:lstStyle/>
           <a:p>
             <a:pPr algn="ctr"/>
+            <a:endParaRPr/>
           </a:p>
         </p:txBody>
       </p:sp>
@@ -4287,6 +4364,7 @@
           <a:lstStyle/>
           <a:p>
             <a:pPr algn="ctr"/>
+            <a:endParaRPr/>
           </a:p>
         </p:txBody>
       </p:sp>
@@ -4333,6 +4411,7 @@
           <a:lstStyle/>
           <a:p>
             <a:pPr algn="ctr"/>
+            <a:endParaRPr/>
           </a:p>
         </p:txBody>
       </p:sp>
@@ -4353,7 +4432,7 @@
           <a:noFill/>
         </p:spPr>
         <p:txBody>
-          <a:bodyPr wrap="square" anchor="t" lIns="0" rIns="0" tIns="0" bIns="0">
+          <a:bodyPr wrap="square" lIns="0" tIns="0" rIns="0" bIns="0" anchor="t">
             <a:spAutoFit/>
           </a:bodyPr>
           <a:lstStyle/>
@@ -4388,7 +4467,7 @@
           <a:noFill/>
         </p:spPr>
         <p:txBody>
-          <a:bodyPr wrap="square" anchor="t" lIns="0" rIns="0" tIns="0" bIns="0">
+          <a:bodyPr wrap="square" lIns="0" tIns="0" rIns="0" bIns="0" anchor="t">
             <a:spAutoFit/>
           </a:bodyPr>
           <a:lstStyle/>
@@ -4424,19 +4503,6 @@
             <a:noFill/>
           </a:ln>
           <a:effectLst/>
-          <a:gradFill rotWithShape="1">
-            <a:gsLst>
-              <a:gs pos="0">
-                <a:srgbClr val="B497CF"/>
-              </a:gs>
-              <a:gs pos="100000">
-                <a:srgbClr val="B497CF">
-                  <a:alpha val="0"/>
-                </a:srgbClr>
-              </a:gs>
-            </a:gsLst>
-            <a:lin ang="0" scaled="1"/>
-          </a:gradFill>
         </p:spPr>
         <p:style>
           <a:lnRef idx="1">
@@ -4457,6 +4523,7 @@
           <a:lstStyle/>
           <a:p>
             <a:pPr algn="ctr"/>
+            <a:endParaRPr/>
           </a:p>
         </p:txBody>
       </p:sp>
@@ -4477,7 +4544,7 @@
           <a:noFill/>
         </p:spPr>
         <p:txBody>
-          <a:bodyPr wrap="square" anchor="t" lIns="0" rIns="0" tIns="0" bIns="0">
+          <a:bodyPr wrap="square" lIns="0" tIns="0" rIns="0" bIns="0" anchor="t">
             <a:spAutoFit/>
           </a:bodyPr>
           <a:lstStyle/>
@@ -4548,6 +4615,7 @@
           <a:lstStyle/>
           <a:p>
             <a:pPr algn="ctr"/>
+            <a:endParaRPr/>
           </a:p>
         </p:txBody>
       </p:sp>
@@ -4568,7 +4636,7 @@
           <a:noFill/>
         </p:spPr>
         <p:txBody>
-          <a:bodyPr wrap="square" anchor="ctr" lIns="0" rIns="0" tIns="0" bIns="0">
+          <a:bodyPr wrap="square" lIns="0" tIns="0" rIns="0" bIns="0" anchor="ctr">
             <a:spAutoFit/>
           </a:bodyPr>
           <a:lstStyle/>
@@ -4637,6 +4705,7 @@
           <a:lstStyle/>
           <a:p>
             <a:pPr algn="ctr"/>
+            <a:endParaRPr/>
           </a:p>
         </p:txBody>
       </p:sp>
@@ -4657,7 +4726,7 @@
           <a:noFill/>
         </p:spPr>
         <p:txBody>
-          <a:bodyPr wrap="square" anchor="t" lIns="0" rIns="0" tIns="0" bIns="0">
+          <a:bodyPr wrap="square" lIns="0" tIns="0" rIns="0" bIns="0" anchor="t">
             <a:spAutoFit/>
           </a:bodyPr>
           <a:lstStyle/>
@@ -4692,7 +4761,7 @@
           <a:noFill/>
         </p:spPr>
         <p:txBody>
-          <a:bodyPr wrap="square" anchor="t" lIns="0" rIns="0" tIns="0" bIns="0">
+          <a:bodyPr wrap="square" lIns="0" tIns="0" rIns="0" bIns="0" anchor="t">
             <a:spAutoFit/>
           </a:bodyPr>
           <a:lstStyle/>
@@ -4763,6 +4832,7 @@
           <a:lstStyle/>
           <a:p>
             <a:pPr algn="ctr"/>
+            <a:endParaRPr/>
           </a:p>
         </p:txBody>
       </p:sp>
@@ -4783,7 +4853,7 @@
           <a:noFill/>
         </p:spPr>
         <p:txBody>
-          <a:bodyPr wrap="square" anchor="t" lIns="0" rIns="0" tIns="0" bIns="0">
+          <a:bodyPr wrap="square" lIns="0" tIns="0" rIns="0" bIns="0" anchor="t">
             <a:spAutoFit/>
           </a:bodyPr>
           <a:lstStyle/>
@@ -4818,7 +4888,7 @@
           <a:noFill/>
         </p:spPr>
         <p:txBody>
-          <a:bodyPr wrap="square" anchor="t" lIns="0" rIns="0" tIns="0" bIns="0">
+          <a:bodyPr wrap="square" lIns="0" tIns="0" rIns="0" bIns="0" anchor="t">
             <a:spAutoFit/>
           </a:bodyPr>
           <a:lstStyle/>
@@ -4889,6 +4959,7 @@
           <a:lstStyle/>
           <a:p>
             <a:pPr algn="ctr"/>
+            <a:endParaRPr/>
           </a:p>
         </p:txBody>
       </p:sp>
@@ -4909,7 +4980,7 @@
           <a:noFill/>
         </p:spPr>
         <p:txBody>
-          <a:bodyPr wrap="square" anchor="t" lIns="0" rIns="0" tIns="0" bIns="0">
+          <a:bodyPr wrap="square" lIns="0" tIns="0" rIns="0" bIns="0" anchor="t">
             <a:spAutoFit/>
           </a:bodyPr>
           <a:lstStyle/>
@@ -4944,7 +5015,7 @@
           <a:noFill/>
         </p:spPr>
         <p:txBody>
-          <a:bodyPr wrap="square" anchor="t" lIns="0" rIns="0" tIns="0" bIns="0">
+          <a:bodyPr wrap="square" lIns="0" tIns="0" rIns="0" bIns="0" anchor="t">
             <a:spAutoFit/>
           </a:bodyPr>
           <a:lstStyle/>
@@ -5015,6 +5086,7 @@
           <a:lstStyle/>
           <a:p>
             <a:pPr algn="ctr"/>
+            <a:endParaRPr/>
           </a:p>
         </p:txBody>
       </p:sp>
@@ -5035,7 +5107,7 @@
           <a:noFill/>
         </p:spPr>
         <p:txBody>
-          <a:bodyPr wrap="square" anchor="t" lIns="0" rIns="0" tIns="0" bIns="0">
+          <a:bodyPr wrap="square" lIns="0" tIns="0" rIns="0" bIns="0" anchor="t">
             <a:spAutoFit/>
           </a:bodyPr>
           <a:lstStyle/>
@@ -5070,7 +5142,7 @@
           <a:noFill/>
         </p:spPr>
         <p:txBody>
-          <a:bodyPr wrap="square" anchor="t" lIns="0" rIns="0" tIns="0" bIns="0">
+          <a:bodyPr wrap="square" lIns="0" tIns="0" rIns="0" bIns="0" anchor="t">
             <a:spAutoFit/>
           </a:bodyPr>
           <a:lstStyle/>
@@ -5141,6 +5213,7 @@
           <a:lstStyle/>
           <a:p>
             <a:pPr algn="ctr"/>
+            <a:endParaRPr/>
           </a:p>
         </p:txBody>
       </p:sp>
@@ -5161,7 +5234,7 @@
           <a:noFill/>
         </p:spPr>
         <p:txBody>
-          <a:bodyPr wrap="square" anchor="t" lIns="0" rIns="0" tIns="0" bIns="0">
+          <a:bodyPr wrap="square" lIns="0" tIns="0" rIns="0" bIns="0" anchor="t">
             <a:spAutoFit/>
           </a:bodyPr>
           <a:lstStyle/>
@@ -5228,6 +5301,7 @@
           <a:lstStyle/>
           <a:p>
             <a:pPr algn="ctr"/>
+            <a:endParaRPr/>
           </a:p>
         </p:txBody>
       </p:sp>
@@ -5248,7 +5322,7 @@
           <a:noFill/>
         </p:spPr>
         <p:txBody>
-          <a:bodyPr wrap="square" anchor="t" lIns="0" rIns="0" tIns="0" bIns="0">
+          <a:bodyPr wrap="square" lIns="0" tIns="0" rIns="0" bIns="0" anchor="t">
             <a:spAutoFit/>
           </a:bodyPr>
           <a:lstStyle/>
@@ -5283,7 +5357,7 @@
           <a:noFill/>
         </p:spPr>
         <p:txBody>
-          <a:bodyPr wrap="square" anchor="t" lIns="0" rIns="0" tIns="0" bIns="0">
+          <a:bodyPr wrap="square" lIns="0" tIns="0" rIns="0" bIns="0" anchor="t">
             <a:spAutoFit/>
           </a:bodyPr>
           <a:lstStyle/>
@@ -5346,6 +5420,7 @@
           <a:lstStyle/>
           <a:p>
             <a:pPr algn="ctr"/>
+            <a:endParaRPr/>
           </a:p>
         </p:txBody>
       </p:sp>
@@ -5374,7 +5449,7 @@
                 <a:srgbClr val="8B85FF"/>
               </a:gs>
             </a:gsLst>
-            <a:lin scaled="0" ang="0"/>
+            <a:lin ang="0" scaled="0"/>
           </a:gradFill>
           <a:ln>
             <a:noFill/>
@@ -5400,6 +5475,7 @@
           <a:lstStyle/>
           <a:p>
             <a:pPr algn="ctr"/>
+            <a:endParaRPr/>
           </a:p>
         </p:txBody>
       </p:sp>
@@ -5420,7 +5496,7 @@
           <a:noFill/>
         </p:spPr>
         <p:txBody>
-          <a:bodyPr wrap="square" anchor="t" lIns="0" rIns="0" tIns="0" bIns="0">
+          <a:bodyPr wrap="square" lIns="0" tIns="0" rIns="0" bIns="0" anchor="t">
             <a:spAutoFit/>
           </a:bodyPr>
           <a:lstStyle/>
@@ -5455,7 +5531,7 @@
           <a:noFill/>
         </p:spPr>
         <p:txBody>
-          <a:bodyPr wrap="square" anchor="t" lIns="0" rIns="0" tIns="0" bIns="0">
+          <a:bodyPr wrap="square" lIns="0" tIns="0" rIns="0" bIns="0" anchor="t">
             <a:spAutoFit/>
           </a:bodyPr>
           <a:lstStyle/>
@@ -5492,7 +5568,7 @@
           <a:noFill/>
         </p:spPr>
         <p:txBody>
-          <a:bodyPr wrap="square" anchor="t" lIns="0" rIns="0" tIns="0" bIns="0">
+          <a:bodyPr wrap="square" lIns="0" tIns="0" rIns="0" bIns="0" anchor="t">
             <a:spAutoFit/>
           </a:bodyPr>
           <a:lstStyle/>
@@ -5529,7 +5605,7 @@
           <a:noFill/>
         </p:spPr>
         <p:txBody>
-          <a:bodyPr wrap="square" anchor="t" lIns="0" rIns="0" tIns="0" bIns="0">
+          <a:bodyPr wrap="square" lIns="0" tIns="0" rIns="0" bIns="0" anchor="t">
             <a:spAutoFit/>
           </a:bodyPr>
           <a:lstStyle/>
@@ -5566,7 +5642,7 @@
           <a:noFill/>
         </p:spPr>
         <p:txBody>
-          <a:bodyPr wrap="square" anchor="t" lIns="0" rIns="0" tIns="0" bIns="0">
+          <a:bodyPr wrap="square" lIns="0" tIns="0" rIns="0" bIns="0" anchor="t">
             <a:spAutoFit/>
           </a:bodyPr>
           <a:lstStyle/>
@@ -5631,6 +5707,7 @@
           <a:lstStyle/>
           <a:p>
             <a:pPr algn="ctr"/>
+            <a:endParaRPr/>
           </a:p>
         </p:txBody>
       </p:sp>
@@ -5651,7 +5728,7 @@
           <a:noFill/>
         </p:spPr>
         <p:txBody>
-          <a:bodyPr wrap="square" anchor="t" lIns="0" rIns="0" tIns="0" bIns="0">
+          <a:bodyPr wrap="square" lIns="0" tIns="0" rIns="0" bIns="0" anchor="t">
             <a:spAutoFit/>
           </a:bodyPr>
           <a:lstStyle/>
@@ -5716,6 +5793,7 @@
           <a:lstStyle/>
           <a:p>
             <a:pPr algn="ctr"/>
+            <a:endParaRPr/>
           </a:p>
         </p:txBody>
       </p:sp>
@@ -5736,7 +5814,7 @@
           <a:noFill/>
         </p:spPr>
         <p:txBody>
-          <a:bodyPr wrap="square" anchor="ctr" lIns="0" rIns="0" tIns="0" bIns="0">
+          <a:bodyPr wrap="square" lIns="0" tIns="0" rIns="0" bIns="0" anchor="ctr">
             <a:spAutoFit/>
           </a:bodyPr>
           <a:lstStyle/>
@@ -5801,6 +5879,7 @@
           <a:lstStyle/>
           <a:p>
             <a:pPr algn="ctr"/>
+            <a:endParaRPr/>
           </a:p>
         </p:txBody>
       </p:sp>
@@ -5821,7 +5900,7 @@
           <a:noFill/>
         </p:spPr>
         <p:txBody>
-          <a:bodyPr wrap="square" anchor="ctr" lIns="0" rIns="0" tIns="0" bIns="0">
+          <a:bodyPr wrap="square" lIns="0" tIns="0" rIns="0" bIns="0" anchor="ctr">
             <a:spAutoFit/>
           </a:bodyPr>
           <a:lstStyle/>
@@ -5886,6 +5965,7 @@
           <a:lstStyle/>
           <a:p>
             <a:pPr algn="ctr"/>
+            <a:endParaRPr/>
           </a:p>
         </p:txBody>
       </p:sp>
@@ -5906,7 +5986,7 @@
           <a:noFill/>
         </p:spPr>
         <p:txBody>
-          <a:bodyPr wrap="square" anchor="ctr" lIns="0" rIns="0" tIns="0" bIns="0">
+          <a:bodyPr wrap="square" lIns="0" tIns="0" rIns="0" bIns="0" anchor="ctr">
             <a:spAutoFit/>
           </a:bodyPr>
           <a:lstStyle/>
@@ -5941,7 +6021,7 @@
           <a:noFill/>
         </p:spPr>
         <p:txBody>
-          <a:bodyPr wrap="square" anchor="t" lIns="0" rIns="0" tIns="0" bIns="0">
+          <a:bodyPr wrap="square" lIns="0" tIns="0" rIns="0" bIns="0" anchor="t">
             <a:spAutoFit/>
           </a:bodyPr>
           <a:lstStyle/>
@@ -6006,6 +6086,7 @@
           <a:lstStyle/>
           <a:p>
             <a:pPr algn="ctr"/>
+            <a:endParaRPr/>
           </a:p>
         </p:txBody>
       </p:sp>
@@ -6054,6 +6135,7 @@
           <a:lstStyle/>
           <a:p>
             <a:pPr algn="ctr"/>
+            <a:endParaRPr/>
           </a:p>
         </p:txBody>
       </p:sp>
@@ -6074,7 +6156,7 @@
           <a:noFill/>
         </p:spPr>
         <p:txBody>
-          <a:bodyPr wrap="square" anchor="t" lIns="0" rIns="0" tIns="0" bIns="0">
+          <a:bodyPr wrap="square" lIns="0" tIns="0" rIns="0" bIns="0" anchor="t">
             <a:spAutoFit/>
           </a:bodyPr>
           <a:lstStyle/>
@@ -6109,7 +6191,7 @@
           <a:noFill/>
         </p:spPr>
         <p:txBody>
-          <a:bodyPr wrap="square" anchor="t" lIns="0" rIns="0" tIns="0" bIns="0">
+          <a:bodyPr wrap="square" lIns="0" tIns="0" rIns="0" bIns="0" anchor="t">
             <a:spAutoFit/>
           </a:bodyPr>
           <a:lstStyle/>
@@ -6174,6 +6256,7 @@
           <a:lstStyle/>
           <a:p>
             <a:pPr algn="ctr"/>
+            <a:endParaRPr/>
           </a:p>
         </p:txBody>
       </p:sp>
@@ -6222,6 +6305,7 @@
           <a:lstStyle/>
           <a:p>
             <a:pPr algn="ctr"/>
+            <a:endParaRPr/>
           </a:p>
         </p:txBody>
       </p:sp>
@@ -6242,7 +6326,7 @@
           <a:noFill/>
         </p:spPr>
         <p:txBody>
-          <a:bodyPr wrap="square" anchor="t" lIns="0" rIns="0" tIns="0" bIns="0">
+          <a:bodyPr wrap="square" lIns="0" tIns="0" rIns="0" bIns="0" anchor="t">
             <a:spAutoFit/>
           </a:bodyPr>
           <a:lstStyle/>
@@ -6277,7 +6361,7 @@
           <a:noFill/>
         </p:spPr>
         <p:txBody>
-          <a:bodyPr wrap="square" anchor="t" lIns="0" rIns="0" tIns="0" bIns="0">
+          <a:bodyPr wrap="square" lIns="0" tIns="0" rIns="0" bIns="0" anchor="t">
             <a:spAutoFit/>
           </a:bodyPr>
           <a:lstStyle/>
@@ -6314,7 +6398,7 @@
           <a:noFill/>
         </p:spPr>
         <p:txBody>
-          <a:bodyPr wrap="square" anchor="t" lIns="0" rIns="0" tIns="0" bIns="0">
+          <a:bodyPr wrap="square" lIns="0" tIns="0" rIns="0" bIns="0" anchor="t">
             <a:spAutoFit/>
           </a:bodyPr>
           <a:lstStyle/>
@@ -6336,17 +6420,26 @@
       </p:sp>
     </p:spTree>
   </p:cSld>
-  <p:transition spd="med">
-    <p:push dir="l"/>
-  </p:transition>
   <p:clrMapOvr>
     <a:masterClrMapping/>
   </p:clrMapOvr>
+  <mc:AlternateContent xmlns:mc="http://schemas.openxmlformats.org/markup-compatibility/2006">
+    <mc:Choice xmlns:p14="http://schemas.microsoft.com/office/powerpoint/2010/main" Requires="p14">
+      <p:transition spd="slow" p14:dur="3900">
+        <p14:glitter pattern="hexagon"/>
+      </p:transition>
+    </mc:Choice>
+    <mc:Fallback>
+      <p:transition spd="slow">
+        <p:fade/>
+      </p:transition>
+    </mc:Fallback>
+  </mc:AlternateContent>
 </p:sld>
 </file>
 
 <file path=ppt/slides/slide3.xml><?xml version="1.0" encoding="utf-8"?>
-<p:sld xmlns:a="http://schemas.openxmlformats.org/drawingml/2006/main" xmlns:p="http://schemas.openxmlformats.org/presentationml/2006/main" xmlns:r="http://schemas.openxmlformats.org/officeDocument/2006/relationships">
+<p:sld xmlns:a="http://schemas.openxmlformats.org/drawingml/2006/main" xmlns:r="http://schemas.openxmlformats.org/officeDocument/2006/relationships" xmlns:p="http://schemas.openxmlformats.org/presentationml/2006/main">
   <p:cSld>
     <p:spTree>
       <p:nvGrpSpPr>
@@ -6354,7 +6447,14 @@
         <p:cNvGrpSpPr/>
         <p:nvPr/>
       </p:nvGrpSpPr>
-      <p:grpSpPr/>
+      <p:grpSpPr>
+        <a:xfrm>
+          <a:off x="0" y="0"/>
+          <a:ext cx="0" cy="0"/>
+          <a:chOff x="0" y="0"/>
+          <a:chExt cx="0" cy="0"/>
+        </a:xfrm>
+      </p:grpSpPr>
       <p:sp>
         <p:nvSpPr>
           <p:cNvPr id="2" name="BGPlate"/>
@@ -6378,7 +6478,7 @@
                 <a:srgbClr val="3B1F7A"/>
               </a:gs>
             </a:gsLst>
-            <a:lin scaled="0" ang="15900000"/>
+            <a:lin ang="15900000" scaled="0"/>
           </a:gradFill>
           <a:ln>
             <a:noFill/>
@@ -6404,6 +6504,7 @@
           <a:lstStyle/>
           <a:p>
             <a:pPr algn="ctr"/>
+            <a:endParaRPr/>
           </a:p>
         </p:txBody>
       </p:sp>
@@ -6450,6 +6551,7 @@
           <a:lstStyle/>
           <a:p>
             <a:pPr algn="ctr"/>
+            <a:endParaRPr/>
           </a:p>
         </p:txBody>
       </p:sp>
@@ -6496,6 +6598,7 @@
           <a:lstStyle/>
           <a:p>
             <a:pPr algn="ctr"/>
+            <a:endParaRPr/>
           </a:p>
         </p:txBody>
       </p:sp>
@@ -6542,6 +6645,7 @@
           <a:lstStyle/>
           <a:p>
             <a:pPr algn="ctr"/>
+            <a:endParaRPr/>
           </a:p>
         </p:txBody>
       </p:sp>
@@ -6588,6 +6692,7 @@
           <a:lstStyle/>
           <a:p>
             <a:pPr algn="ctr"/>
+            <a:endParaRPr/>
           </a:p>
         </p:txBody>
       </p:sp>
@@ -6608,7 +6713,7 @@
           <a:noFill/>
         </p:spPr>
         <p:txBody>
-          <a:bodyPr wrap="square" anchor="t" lIns="0" rIns="0" tIns="0" bIns="0">
+          <a:bodyPr wrap="square" lIns="0" tIns="0" rIns="0" bIns="0" anchor="t">
             <a:spAutoFit/>
           </a:bodyPr>
           <a:lstStyle/>
@@ -6643,7 +6748,7 @@
           <a:noFill/>
         </p:spPr>
         <p:txBody>
-          <a:bodyPr wrap="square" anchor="t" lIns="0" rIns="0" tIns="0" bIns="0">
+          <a:bodyPr wrap="square" lIns="0" tIns="0" rIns="0" bIns="0" anchor="t">
             <a:spAutoFit/>
           </a:bodyPr>
           <a:lstStyle/>
@@ -6679,19 +6784,6 @@
             <a:noFill/>
           </a:ln>
           <a:effectLst/>
-          <a:gradFill rotWithShape="1">
-            <a:gsLst>
-              <a:gs pos="0">
-                <a:srgbClr val="B497CF"/>
-              </a:gs>
-              <a:gs pos="100000">
-                <a:srgbClr val="B497CF">
-                  <a:alpha val="0"/>
-                </a:srgbClr>
-              </a:gs>
-            </a:gsLst>
-            <a:lin ang="0" scaled="1"/>
-          </a:gradFill>
         </p:spPr>
         <p:style>
           <a:lnRef idx="1">
@@ -6712,6 +6804,7 @@
           <a:lstStyle/>
           <a:p>
             <a:pPr algn="ctr"/>
+            <a:endParaRPr/>
           </a:p>
         </p:txBody>
       </p:sp>
@@ -6762,6 +6855,7 @@
           <a:lstStyle/>
           <a:p>
             <a:pPr algn="ctr"/>
+            <a:endParaRPr/>
           </a:p>
         </p:txBody>
       </p:sp>
@@ -6782,7 +6876,7 @@
           <a:noFill/>
         </p:spPr>
         <p:txBody>
-          <a:bodyPr wrap="square" anchor="ctr" lIns="0" rIns="0" tIns="0" bIns="0">
+          <a:bodyPr wrap="square" lIns="0" tIns="0" rIns="0" bIns="0" anchor="ctr">
             <a:spAutoFit/>
           </a:bodyPr>
           <a:lstStyle/>
@@ -6822,7 +6916,7 @@
           <a:noFill/>
         </p:spPr>
         <p:txBody>
-          <a:bodyPr wrap="square" anchor="ctr" lIns="0" rIns="0" tIns="0" bIns="0">
+          <a:bodyPr wrap="square" lIns="0" tIns="0" rIns="0" bIns="0" anchor="ctr">
             <a:spAutoFit/>
           </a:bodyPr>
           <a:lstStyle/>
@@ -6887,6 +6981,7 @@
           <a:lstStyle/>
           <a:p>
             <a:pPr algn="ctr"/>
+            <a:endParaRPr/>
           </a:p>
         </p:txBody>
       </p:sp>
@@ -6907,7 +7002,7 @@
           <a:noFill/>
         </p:spPr>
         <p:txBody>
-          <a:bodyPr wrap="square" anchor="ctr" lIns="0" rIns="0" tIns="0" bIns="0">
+          <a:bodyPr wrap="square" lIns="0" tIns="0" rIns="0" bIns="0" anchor="ctr">
             <a:spAutoFit/>
           </a:bodyPr>
           <a:lstStyle/>
@@ -6947,7 +7042,7 @@
           <a:noFill/>
         </p:spPr>
         <p:txBody>
-          <a:bodyPr wrap="square" anchor="ctr" lIns="0" rIns="0" tIns="0" bIns="0">
+          <a:bodyPr wrap="square" lIns="0" tIns="0" rIns="0" bIns="0" anchor="ctr">
             <a:spAutoFit/>
           </a:bodyPr>
           <a:lstStyle/>
@@ -7012,6 +7107,7 @@
           <a:lstStyle/>
           <a:p>
             <a:pPr algn="ctr"/>
+            <a:endParaRPr/>
           </a:p>
         </p:txBody>
       </p:sp>
@@ -7032,7 +7128,7 @@
           <a:noFill/>
         </p:spPr>
         <p:txBody>
-          <a:bodyPr wrap="square" anchor="ctr" lIns="0" rIns="0" tIns="0" bIns="0">
+          <a:bodyPr wrap="square" lIns="0" tIns="0" rIns="0" bIns="0" anchor="ctr">
             <a:spAutoFit/>
           </a:bodyPr>
           <a:lstStyle/>
@@ -7102,6 +7198,7 @@
           <a:lstStyle/>
           <a:p>
             <a:pPr algn="ctr"/>
+            <a:endParaRPr/>
           </a:p>
         </p:txBody>
       </p:sp>
@@ -7122,7 +7219,7 @@
           <a:noFill/>
         </p:spPr>
         <p:txBody>
-          <a:bodyPr wrap="square" anchor="ctr" lIns="0" rIns="0" tIns="0" bIns="0">
+          <a:bodyPr wrap="square" lIns="0" tIns="0" rIns="0" bIns="0" anchor="ctr">
             <a:spAutoFit/>
           </a:bodyPr>
           <a:lstStyle/>
@@ -7162,7 +7259,7 @@
           <a:noFill/>
         </p:spPr>
         <p:txBody>
-          <a:bodyPr wrap="square" anchor="ctr" lIns="0" rIns="0" tIns="0" bIns="0">
+          <a:bodyPr wrap="square" lIns="0" tIns="0" rIns="0" bIns="0" anchor="ctr">
             <a:spAutoFit/>
           </a:bodyPr>
           <a:lstStyle/>
@@ -7227,6 +7324,7 @@
           <a:lstStyle/>
           <a:p>
             <a:pPr algn="ctr"/>
+            <a:endParaRPr/>
           </a:p>
         </p:txBody>
       </p:sp>
@@ -7238,8 +7336,8 @@
         </p:nvSpPr>
         <p:spPr>
           <a:xfrm>
-            <a:off x="2578608" y="3520440"/>
-            <a:ext cx="1353312" cy="960120"/>
+            <a:off x="2578608" y="3704617"/>
+            <a:ext cx="1353312" cy="591765"/>
           </a:xfrm>
           <a:prstGeom prst="rect">
             <a:avLst/>
@@ -7247,7 +7345,7 @@
           <a:noFill/>
         </p:spPr>
         <p:txBody>
-          <a:bodyPr wrap="square" anchor="ctr" lIns="0" rIns="0" tIns="0" bIns="0">
+          <a:bodyPr wrap="square" lIns="0" tIns="0" rIns="0" bIns="0" anchor="ctr">
             <a:spAutoFit/>
           </a:bodyPr>
           <a:lstStyle/>
@@ -7258,15 +7356,29 @@
               </a:lnSpc>
             </a:pPr>
             <a:r>
-              <a:rPr sz="1250" b="1" i="0">
+              <a:rPr lang="en-IN" sz="1250" b="1" dirty="0">
                 <a:solidFill>
                   <a:srgbClr val="FFFFFF"/>
                 </a:solidFill>
                 <a:latin typeface="Segoe UI"/>
               </a:rPr>
-              <a:t>Risk
-Detection</a:t>
-            </a:r>
+              <a:t>Leaderboard based </a:t>
+            </a:r>
+            <a:r>
+              <a:rPr lang="en-IN" sz="1250" b="1" dirty="0" err="1">
+                <a:solidFill>
+                  <a:srgbClr val="FFFFFF"/>
+                </a:solidFill>
+                <a:latin typeface="Segoe UI"/>
+              </a:rPr>
+              <a:t>competative</a:t>
+            </a:r>
+            <a:endParaRPr sz="1250" b="1" i="0" dirty="0">
+              <a:solidFill>
+                <a:srgbClr val="FFFFFF"/>
+              </a:solidFill>
+              <a:latin typeface="Segoe UI"/>
+            </a:endParaRPr>
           </a:p>
         </p:txBody>
       </p:sp>
@@ -7287,7 +7399,7 @@
           <a:noFill/>
         </p:spPr>
         <p:txBody>
-          <a:bodyPr wrap="square" anchor="ctr" lIns="0" rIns="0" tIns="0" bIns="0">
+          <a:bodyPr wrap="square" lIns="0" tIns="0" rIns="0" bIns="0" anchor="ctr">
             <a:spAutoFit/>
           </a:bodyPr>
           <a:lstStyle/>
@@ -7352,6 +7464,7 @@
           <a:lstStyle/>
           <a:p>
             <a:pPr algn="ctr"/>
+            <a:endParaRPr/>
           </a:p>
         </p:txBody>
       </p:sp>
@@ -7372,7 +7485,7 @@
           <a:noFill/>
         </p:spPr>
         <p:txBody>
-          <a:bodyPr wrap="square" anchor="ctr" lIns="0" rIns="0" tIns="0" bIns="0">
+          <a:bodyPr wrap="square" lIns="0" tIns="0" rIns="0" bIns="0" anchor="ctr">
             <a:spAutoFit/>
           </a:bodyPr>
           <a:lstStyle/>
@@ -7412,7 +7525,7 @@
           <a:noFill/>
         </p:spPr>
         <p:txBody>
-          <a:bodyPr wrap="square" anchor="ctr" lIns="0" rIns="0" tIns="0" bIns="0">
+          <a:bodyPr wrap="square" lIns="0" tIns="0" rIns="0" bIns="0" anchor="ctr">
             <a:spAutoFit/>
           </a:bodyPr>
           <a:lstStyle/>
@@ -7477,6 +7590,7 @@
           <a:lstStyle/>
           <a:p>
             <a:pPr algn="ctr"/>
+            <a:endParaRPr/>
           </a:p>
         </p:txBody>
       </p:sp>
@@ -7497,7 +7611,7 @@
           <a:noFill/>
         </p:spPr>
         <p:txBody>
-          <a:bodyPr wrap="square" anchor="t" lIns="0" rIns="0" tIns="0" bIns="0">
+          <a:bodyPr wrap="square" lIns="0" tIns="0" rIns="0" bIns="0" anchor="t">
             <a:spAutoFit/>
           </a:bodyPr>
           <a:lstStyle/>
@@ -7558,6 +7672,7 @@
           <a:lstStyle/>
           <a:p>
             <a:pPr algn="ctr"/>
+            <a:endParaRPr/>
           </a:p>
         </p:txBody>
       </p:sp>
@@ -7578,7 +7693,7 @@
           <a:noFill/>
         </p:spPr>
         <p:txBody>
-          <a:bodyPr wrap="square" anchor="t" lIns="0" rIns="0" tIns="0" bIns="0">
+          <a:bodyPr wrap="square" lIns="0" tIns="0" rIns="0" bIns="0" anchor="t">
             <a:spAutoFit/>
           </a:bodyPr>
           <a:lstStyle/>
@@ -7641,6 +7756,7 @@
           <a:lstStyle/>
           <a:p>
             <a:pPr algn="ctr"/>
+            <a:endParaRPr/>
           </a:p>
         </p:txBody>
       </p:sp>
@@ -7661,7 +7777,7 @@
           <a:noFill/>
         </p:spPr>
         <p:txBody>
-          <a:bodyPr wrap="square" anchor="t" lIns="0" rIns="0" tIns="0" bIns="0">
+          <a:bodyPr wrap="square" lIns="0" tIns="0" rIns="0" bIns="0" anchor="t">
             <a:spAutoFit/>
           </a:bodyPr>
           <a:lstStyle/>
@@ -7728,6 +7844,7 @@
           <a:lstStyle/>
           <a:p>
             <a:pPr algn="ctr"/>
+            <a:endParaRPr/>
           </a:p>
         </p:txBody>
       </p:sp>
@@ -7748,7 +7865,7 @@
           <a:noFill/>
         </p:spPr>
         <p:txBody>
-          <a:bodyPr wrap="square" anchor="t" lIns="0" rIns="0" tIns="0" bIns="0">
+          <a:bodyPr wrap="square" lIns="0" tIns="0" rIns="0" bIns="0" anchor="t">
             <a:spAutoFit/>
           </a:bodyPr>
           <a:lstStyle/>
@@ -7813,6 +7930,7 @@
           <a:lstStyle/>
           <a:p>
             <a:pPr algn="ctr"/>
+            <a:endParaRPr/>
           </a:p>
         </p:txBody>
       </p:sp>
@@ -7833,7 +7951,7 @@
           <a:noFill/>
         </p:spPr>
         <p:txBody>
-          <a:bodyPr wrap="square" anchor="ctr" lIns="0" rIns="0" tIns="0" bIns="0">
+          <a:bodyPr wrap="square" lIns="0" tIns="0" rIns="0" bIns="0" anchor="ctr">
             <a:spAutoFit/>
           </a:bodyPr>
           <a:lstStyle/>
@@ -7898,6 +8016,7 @@
           <a:lstStyle/>
           <a:p>
             <a:pPr algn="ctr"/>
+            <a:endParaRPr/>
           </a:p>
         </p:txBody>
       </p:sp>
@@ -7918,7 +8037,7 @@
           <a:noFill/>
         </p:spPr>
         <p:txBody>
-          <a:bodyPr wrap="square" anchor="ctr" lIns="0" rIns="0" tIns="0" bIns="0">
+          <a:bodyPr wrap="square" lIns="0" tIns="0" rIns="0" bIns="0" anchor="ctr">
             <a:spAutoFit/>
           </a:bodyPr>
           <a:lstStyle/>
@@ -7983,6 +8102,7 @@
           <a:lstStyle/>
           <a:p>
             <a:pPr algn="ctr"/>
+            <a:endParaRPr/>
           </a:p>
         </p:txBody>
       </p:sp>
@@ -8003,7 +8123,7 @@
           <a:noFill/>
         </p:spPr>
         <p:txBody>
-          <a:bodyPr wrap="square" anchor="ctr" lIns="0" rIns="0" tIns="0" bIns="0">
+          <a:bodyPr wrap="square" lIns="0" tIns="0" rIns="0" bIns="0" anchor="ctr">
             <a:spAutoFit/>
           </a:bodyPr>
           <a:lstStyle/>
@@ -8068,6 +8188,7 @@
           <a:lstStyle/>
           <a:p>
             <a:pPr algn="ctr"/>
+            <a:endParaRPr/>
           </a:p>
         </p:txBody>
       </p:sp>
@@ -8088,7 +8209,7 @@
           <a:noFill/>
         </p:spPr>
         <p:txBody>
-          <a:bodyPr wrap="square" anchor="ctr" lIns="0" rIns="0" tIns="0" bIns="0">
+          <a:bodyPr wrap="square" lIns="0" tIns="0" rIns="0" bIns="0" anchor="ctr">
             <a:spAutoFit/>
           </a:bodyPr>
           <a:lstStyle/>
@@ -8153,6 +8274,7 @@
           <a:lstStyle/>
           <a:p>
             <a:pPr algn="ctr"/>
+            <a:endParaRPr/>
           </a:p>
         </p:txBody>
       </p:sp>
@@ -8173,7 +8295,7 @@
           <a:noFill/>
         </p:spPr>
         <p:txBody>
-          <a:bodyPr wrap="square" anchor="ctr" lIns="0" rIns="0" tIns="0" bIns="0">
+          <a:bodyPr wrap="square" lIns="0" tIns="0" rIns="0" bIns="0" anchor="ctr">
             <a:spAutoFit/>
           </a:bodyPr>
           <a:lstStyle/>
@@ -8208,7 +8330,7 @@
           <a:noFill/>
         </p:spPr>
         <p:txBody>
-          <a:bodyPr wrap="square" anchor="t" lIns="0" rIns="0" tIns="0" bIns="0">
+          <a:bodyPr wrap="square" lIns="0" tIns="0" rIns="0" bIns="0" anchor="t">
             <a:spAutoFit/>
           </a:bodyPr>
           <a:lstStyle/>
@@ -8245,7 +8367,7 @@
           <a:noFill/>
         </p:spPr>
         <p:txBody>
-          <a:bodyPr wrap="square" anchor="t" lIns="0" rIns="0" tIns="0" bIns="0">
+          <a:bodyPr wrap="square" lIns="0" tIns="0" rIns="0" bIns="0" anchor="t">
             <a:spAutoFit/>
           </a:bodyPr>
           <a:lstStyle/>
@@ -8267,17 +8389,36 @@
       </p:sp>
     </p:spTree>
   </p:cSld>
-  <p:transition spd="med">
-    <p:wipe dir="r"/>
-  </p:transition>
   <p:clrMapOvr>
     <a:masterClrMapping/>
   </p:clrMapOvr>
+  <mc:AlternateContent xmlns:mc="http://schemas.openxmlformats.org/markup-compatibility/2006">
+    <mc:Choice xmlns:p14="http://schemas.microsoft.com/office/powerpoint/2010/main" Requires="p14">
+      <p:transition spd="slow" p14:dur="4000">
+        <p14:honeycomb/>
+        <p:sndAc>
+          <p:stSnd>
+            <p:snd r:embed="rId2" name="whoosh.wav"/>
+          </p:stSnd>
+        </p:sndAc>
+      </p:transition>
+    </mc:Choice>
+    <mc:Fallback>
+      <p:transition spd="slow">
+        <p:fade/>
+        <p:sndAc>
+          <p:stSnd>
+            <p:snd r:embed="rId2" name="whoosh.wav"/>
+          </p:stSnd>
+        </p:sndAc>
+      </p:transition>
+    </mc:Fallback>
+  </mc:AlternateContent>
 </p:sld>
 </file>
 
 <file path=ppt/slides/slide4.xml><?xml version="1.0" encoding="utf-8"?>
-<p:sld xmlns:a="http://schemas.openxmlformats.org/drawingml/2006/main" xmlns:p="http://schemas.openxmlformats.org/presentationml/2006/main" xmlns:r="http://schemas.openxmlformats.org/officeDocument/2006/relationships">
+<p:sld xmlns:a="http://schemas.openxmlformats.org/drawingml/2006/main" xmlns:r="http://schemas.openxmlformats.org/officeDocument/2006/relationships" xmlns:p="http://schemas.openxmlformats.org/presentationml/2006/main">
   <p:cSld>
     <p:spTree>
       <p:nvGrpSpPr>
@@ -8285,7 +8426,14 @@
         <p:cNvGrpSpPr/>
         <p:nvPr/>
       </p:nvGrpSpPr>
-      <p:grpSpPr/>
+      <p:grpSpPr>
+        <a:xfrm>
+          <a:off x="0" y="0"/>
+          <a:ext cx="0" cy="0"/>
+          <a:chOff x="0" y="0"/>
+          <a:chExt cx="0" cy="0"/>
+        </a:xfrm>
+      </p:grpSpPr>
       <p:sp>
         <p:nvSpPr>
           <p:cNvPr id="2" name="BGPlate"/>
@@ -8309,7 +8457,7 @@
                 <a:srgbClr val="3B1F7A"/>
               </a:gs>
             </a:gsLst>
-            <a:lin scaled="0" ang="15300000"/>
+            <a:lin ang="15300000" scaled="0"/>
           </a:gradFill>
           <a:ln>
             <a:noFill/>
@@ -8335,6 +8483,7 @@
           <a:lstStyle/>
           <a:p>
             <a:pPr algn="ctr"/>
+            <a:endParaRPr/>
           </a:p>
         </p:txBody>
       </p:sp>
@@ -8381,6 +8530,7 @@
           <a:lstStyle/>
           <a:p>
             <a:pPr algn="ctr"/>
+            <a:endParaRPr/>
           </a:p>
         </p:txBody>
       </p:sp>
@@ -8427,6 +8577,7 @@
           <a:lstStyle/>
           <a:p>
             <a:pPr algn="ctr"/>
+            <a:endParaRPr/>
           </a:p>
         </p:txBody>
       </p:sp>
@@ -8473,6 +8624,7 @@
           <a:lstStyle/>
           <a:p>
             <a:pPr algn="ctr"/>
+            <a:endParaRPr/>
           </a:p>
         </p:txBody>
       </p:sp>
@@ -8519,6 +8671,7 @@
           <a:lstStyle/>
           <a:p>
             <a:pPr algn="ctr"/>
+            <a:endParaRPr/>
           </a:p>
         </p:txBody>
       </p:sp>
@@ -8539,7 +8692,7 @@
           <a:noFill/>
         </p:spPr>
         <p:txBody>
-          <a:bodyPr wrap="square" anchor="t" lIns="0" rIns="0" tIns="0" bIns="0">
+          <a:bodyPr wrap="square" lIns="0" tIns="0" rIns="0" bIns="0" anchor="t">
             <a:spAutoFit/>
           </a:bodyPr>
           <a:lstStyle/>
@@ -8574,7 +8727,7 @@
           <a:noFill/>
         </p:spPr>
         <p:txBody>
-          <a:bodyPr wrap="square" anchor="t" lIns="0" rIns="0" tIns="0" bIns="0">
+          <a:bodyPr wrap="square" lIns="0" tIns="0" rIns="0" bIns="0" anchor="t">
             <a:spAutoFit/>
           </a:bodyPr>
           <a:lstStyle/>
@@ -8610,19 +8763,6 @@
             <a:noFill/>
           </a:ln>
           <a:effectLst/>
-          <a:gradFill rotWithShape="1">
-            <a:gsLst>
-              <a:gs pos="0">
-                <a:srgbClr val="B497CF"/>
-              </a:gs>
-              <a:gs pos="100000">
-                <a:srgbClr val="B497CF">
-                  <a:alpha val="0"/>
-                </a:srgbClr>
-              </a:gs>
-            </a:gsLst>
-            <a:lin ang="0" scaled="1"/>
-          </a:gradFill>
         </p:spPr>
         <p:style>
           <a:lnRef idx="1">
@@ -8643,6 +8783,7 @@
           <a:lstStyle/>
           <a:p>
             <a:pPr algn="ctr"/>
+            <a:endParaRPr/>
           </a:p>
         </p:txBody>
       </p:sp>
@@ -8693,6 +8834,7 @@
           <a:lstStyle/>
           <a:p>
             <a:pPr algn="ctr"/>
+            <a:endParaRPr/>
           </a:p>
         </p:txBody>
       </p:sp>
@@ -8713,7 +8855,7 @@
           <a:noFill/>
         </p:spPr>
         <p:txBody>
-          <a:bodyPr wrap="square" anchor="t" lIns="0" rIns="0" tIns="0" bIns="0">
+          <a:bodyPr wrap="square" lIns="0" tIns="0" rIns="0" bIns="0" anchor="t">
             <a:spAutoFit/>
           </a:bodyPr>
           <a:lstStyle/>
@@ -8776,6 +8918,7 @@
           <a:lstStyle/>
           <a:p>
             <a:pPr algn="ctr"/>
+            <a:endParaRPr/>
           </a:p>
         </p:txBody>
       </p:sp>
@@ -8796,7 +8939,7 @@
           <a:noFill/>
         </p:spPr>
         <p:txBody>
-          <a:bodyPr wrap="square" anchor="ctr" lIns="0" rIns="0" tIns="0" bIns="0">
+          <a:bodyPr wrap="square" lIns="0" tIns="0" rIns="0" bIns="0" anchor="ctr">
             <a:spAutoFit/>
           </a:bodyPr>
           <a:lstStyle/>
@@ -8831,7 +8974,7 @@
           <a:noFill/>
         </p:spPr>
         <p:txBody>
-          <a:bodyPr wrap="square" anchor="t" lIns="0" rIns="0" tIns="0" bIns="0">
+          <a:bodyPr wrap="square" lIns="0" tIns="0" rIns="0" bIns="0" anchor="t">
             <a:spAutoFit/>
           </a:bodyPr>
           <a:lstStyle/>
@@ -8900,6 +9043,7 @@
           <a:lstStyle/>
           <a:p>
             <a:pPr algn="ctr"/>
+            <a:endParaRPr/>
           </a:p>
         </p:txBody>
       </p:sp>
@@ -8920,7 +9064,7 @@
           <a:noFill/>
         </p:spPr>
         <p:txBody>
-          <a:bodyPr wrap="square" anchor="ctr" lIns="0" rIns="0" tIns="0" bIns="0">
+          <a:bodyPr wrap="square" lIns="0" tIns="0" rIns="0" bIns="0" anchor="ctr">
             <a:spAutoFit/>
           </a:bodyPr>
           <a:lstStyle/>
@@ -8955,7 +9099,7 @@
           <a:noFill/>
         </p:spPr>
         <p:txBody>
-          <a:bodyPr wrap="square" anchor="t" lIns="0" rIns="0" tIns="0" bIns="0">
+          <a:bodyPr wrap="square" lIns="0" tIns="0" rIns="0" bIns="0" anchor="t">
             <a:spAutoFit/>
           </a:bodyPr>
           <a:lstStyle/>
@@ -9024,6 +9168,7 @@
           <a:lstStyle/>
           <a:p>
             <a:pPr algn="ctr"/>
+            <a:endParaRPr/>
           </a:p>
         </p:txBody>
       </p:sp>
@@ -9044,7 +9189,7 @@
           <a:noFill/>
         </p:spPr>
         <p:txBody>
-          <a:bodyPr wrap="square" anchor="ctr" lIns="0" rIns="0" tIns="0" bIns="0">
+          <a:bodyPr wrap="square" lIns="0" tIns="0" rIns="0" bIns="0" anchor="ctr">
             <a:spAutoFit/>
           </a:bodyPr>
           <a:lstStyle/>
@@ -9079,7 +9224,7 @@
           <a:noFill/>
         </p:spPr>
         <p:txBody>
-          <a:bodyPr wrap="square" anchor="t" lIns="0" rIns="0" tIns="0" bIns="0">
+          <a:bodyPr wrap="square" lIns="0" tIns="0" rIns="0" bIns="0" anchor="t">
             <a:spAutoFit/>
           </a:bodyPr>
           <a:lstStyle/>
@@ -9148,6 +9293,7 @@
           <a:lstStyle/>
           <a:p>
             <a:pPr algn="ctr"/>
+            <a:endParaRPr/>
           </a:p>
         </p:txBody>
       </p:sp>
@@ -9168,7 +9314,7 @@
           <a:noFill/>
         </p:spPr>
         <p:txBody>
-          <a:bodyPr wrap="square" anchor="ctr" lIns="0" rIns="0" tIns="0" bIns="0">
+          <a:bodyPr wrap="square" lIns="0" tIns="0" rIns="0" bIns="0" anchor="ctr">
             <a:spAutoFit/>
           </a:bodyPr>
           <a:lstStyle/>
@@ -9203,7 +9349,7 @@
           <a:noFill/>
         </p:spPr>
         <p:txBody>
-          <a:bodyPr wrap="square" anchor="t" lIns="0" rIns="0" tIns="0" bIns="0">
+          <a:bodyPr wrap="square" lIns="0" tIns="0" rIns="0" bIns="0" anchor="t">
             <a:spAutoFit/>
           </a:bodyPr>
           <a:lstStyle/>
@@ -9272,6 +9418,7 @@
           <a:lstStyle/>
           <a:p>
             <a:pPr algn="ctr"/>
+            <a:endParaRPr/>
           </a:p>
         </p:txBody>
       </p:sp>
@@ -9292,7 +9439,7 @@
           <a:noFill/>
         </p:spPr>
         <p:txBody>
-          <a:bodyPr wrap="square" anchor="ctr" lIns="0" rIns="0" tIns="0" bIns="0">
+          <a:bodyPr wrap="square" lIns="0" tIns="0" rIns="0" bIns="0" anchor="ctr">
             <a:spAutoFit/>
           </a:bodyPr>
           <a:lstStyle/>
@@ -9327,7 +9474,7 @@
           <a:noFill/>
         </p:spPr>
         <p:txBody>
-          <a:bodyPr wrap="square" anchor="t" lIns="0" rIns="0" tIns="0" bIns="0">
+          <a:bodyPr wrap="square" lIns="0" tIns="0" rIns="0" bIns="0" anchor="t">
             <a:spAutoFit/>
           </a:bodyPr>
           <a:lstStyle/>
@@ -9396,6 +9543,7 @@
           <a:lstStyle/>
           <a:p>
             <a:pPr algn="ctr"/>
+            <a:endParaRPr/>
           </a:p>
         </p:txBody>
       </p:sp>
@@ -9416,7 +9564,7 @@
           <a:noFill/>
         </p:spPr>
         <p:txBody>
-          <a:bodyPr wrap="square" anchor="ctr" lIns="0" rIns="0" tIns="0" bIns="0">
+          <a:bodyPr wrap="square" lIns="0" tIns="0" rIns="0" bIns="0" anchor="ctr">
             <a:spAutoFit/>
           </a:bodyPr>
           <a:lstStyle/>
@@ -9451,7 +9599,7 @@
           <a:noFill/>
         </p:spPr>
         <p:txBody>
-          <a:bodyPr wrap="square" anchor="t" lIns="0" rIns="0" tIns="0" bIns="0">
+          <a:bodyPr wrap="square" lIns="0" tIns="0" rIns="0" bIns="0" anchor="t">
             <a:spAutoFit/>
           </a:bodyPr>
           <a:lstStyle/>
@@ -9520,6 +9668,7 @@
           <a:lstStyle/>
           <a:p>
             <a:pPr algn="ctr"/>
+            <a:endParaRPr/>
           </a:p>
         </p:txBody>
       </p:sp>
@@ -9540,7 +9689,7 @@
           <a:noFill/>
         </p:spPr>
         <p:txBody>
-          <a:bodyPr wrap="square" anchor="ctr" lIns="0" rIns="0" tIns="0" bIns="0">
+          <a:bodyPr wrap="square" lIns="0" tIns="0" rIns="0" bIns="0" anchor="ctr">
             <a:spAutoFit/>
           </a:bodyPr>
           <a:lstStyle/>
@@ -9575,7 +9724,7 @@
           <a:noFill/>
         </p:spPr>
         <p:txBody>
-          <a:bodyPr wrap="square" anchor="t" lIns="0" rIns="0" tIns="0" bIns="0">
+          <a:bodyPr wrap="square" lIns="0" tIns="0" rIns="0" bIns="0" anchor="t">
             <a:spAutoFit/>
           </a:bodyPr>
           <a:lstStyle/>
@@ -9644,6 +9793,7 @@
           <a:lstStyle/>
           <a:p>
             <a:pPr algn="ctr"/>
+            <a:endParaRPr/>
           </a:p>
         </p:txBody>
       </p:sp>
@@ -9664,7 +9814,7 @@
           <a:noFill/>
         </p:spPr>
         <p:txBody>
-          <a:bodyPr wrap="square" anchor="ctr" lIns="0" rIns="0" tIns="0" bIns="0">
+          <a:bodyPr wrap="square" lIns="0" tIns="0" rIns="0" bIns="0" anchor="ctr">
             <a:spAutoFit/>
           </a:bodyPr>
           <a:lstStyle/>
@@ -9699,7 +9849,7 @@
           <a:noFill/>
         </p:spPr>
         <p:txBody>
-          <a:bodyPr wrap="square" anchor="t" lIns="0" rIns="0" tIns="0" bIns="0">
+          <a:bodyPr wrap="square" lIns="0" tIns="0" rIns="0" bIns="0" anchor="t">
             <a:spAutoFit/>
           </a:bodyPr>
           <a:lstStyle/>
@@ -9770,6 +9920,7 @@
           <a:lstStyle/>
           <a:p>
             <a:pPr algn="ctr"/>
+            <a:endParaRPr/>
           </a:p>
         </p:txBody>
       </p:sp>
@@ -9790,7 +9941,7 @@
           <a:noFill/>
         </p:spPr>
         <p:txBody>
-          <a:bodyPr wrap="square" anchor="t" lIns="0" rIns="0" tIns="0" bIns="0">
+          <a:bodyPr wrap="square" lIns="0" tIns="0" rIns="0" bIns="0" anchor="t">
             <a:spAutoFit/>
           </a:bodyPr>
           <a:lstStyle/>
@@ -9825,7 +9976,7 @@
           <a:noFill/>
         </p:spPr>
         <p:txBody>
-          <a:bodyPr wrap="square" anchor="t" lIns="0" rIns="0" tIns="0" bIns="0">
+          <a:bodyPr wrap="square" lIns="0" tIns="0" rIns="0" bIns="0" anchor="t">
             <a:spAutoFit/>
           </a:bodyPr>
           <a:lstStyle/>
@@ -9860,7 +10011,7 @@
           <a:noFill/>
         </p:spPr>
         <p:txBody>
-          <a:bodyPr wrap="square" anchor="t" lIns="0" rIns="0" tIns="0" bIns="0">
+          <a:bodyPr wrap="square" lIns="0" tIns="0" rIns="0" bIns="0" anchor="t">
             <a:spAutoFit/>
           </a:bodyPr>
           <a:lstStyle/>
@@ -9901,7 +10052,7 @@
           <a:noFill/>
         </p:spPr>
         <p:txBody>
-          <a:bodyPr wrap="square" anchor="t" lIns="0" rIns="0" tIns="0" bIns="0">
+          <a:bodyPr wrap="square" lIns="0" tIns="0" rIns="0" bIns="0" anchor="t">
             <a:spAutoFit/>
           </a:bodyPr>
           <a:lstStyle/>
@@ -9936,7 +10087,7 @@
           <a:noFill/>
         </p:spPr>
         <p:txBody>
-          <a:bodyPr wrap="square" anchor="t" lIns="0" rIns="0" tIns="0" bIns="0">
+          <a:bodyPr wrap="square" lIns="0" tIns="0" rIns="0" bIns="0" anchor="t">
             <a:spAutoFit/>
           </a:bodyPr>
           <a:lstStyle/>
@@ -9977,7 +10128,7 @@
           <a:noFill/>
         </p:spPr>
         <p:txBody>
-          <a:bodyPr wrap="square" anchor="t" lIns="0" rIns="0" tIns="0" bIns="0">
+          <a:bodyPr wrap="square" lIns="0" tIns="0" rIns="0" bIns="0" anchor="t">
             <a:spAutoFit/>
           </a:bodyPr>
           <a:lstStyle/>
@@ -10012,7 +10163,7 @@
           <a:noFill/>
         </p:spPr>
         <p:txBody>
-          <a:bodyPr wrap="square" anchor="t" lIns="0" rIns="0" tIns="0" bIns="0">
+          <a:bodyPr wrap="square" lIns="0" tIns="0" rIns="0" bIns="0" anchor="t">
             <a:spAutoFit/>
           </a:bodyPr>
           <a:lstStyle/>
@@ -10053,7 +10204,7 @@
           <a:noFill/>
         </p:spPr>
         <p:txBody>
-          <a:bodyPr wrap="square" anchor="t" lIns="0" rIns="0" tIns="0" bIns="0">
+          <a:bodyPr wrap="square" lIns="0" tIns="0" rIns="0" bIns="0" anchor="t">
             <a:spAutoFit/>
           </a:bodyPr>
           <a:lstStyle/>
@@ -10088,7 +10239,7 @@
           <a:noFill/>
         </p:spPr>
         <p:txBody>
-          <a:bodyPr wrap="square" anchor="t" lIns="0" rIns="0" tIns="0" bIns="0">
+          <a:bodyPr wrap="square" lIns="0" tIns="0" rIns="0" bIns="0" anchor="t">
             <a:spAutoFit/>
           </a:bodyPr>
           <a:lstStyle/>
@@ -10129,7 +10280,7 @@
           <a:noFill/>
         </p:spPr>
         <p:txBody>
-          <a:bodyPr wrap="square" anchor="t" lIns="0" rIns="0" tIns="0" bIns="0">
+          <a:bodyPr wrap="square" lIns="0" tIns="0" rIns="0" bIns="0" anchor="t">
             <a:spAutoFit/>
           </a:bodyPr>
           <a:lstStyle/>
@@ -10166,7 +10317,7 @@
           <a:noFill/>
         </p:spPr>
         <p:txBody>
-          <a:bodyPr wrap="square" anchor="t" lIns="0" rIns="0" tIns="0" bIns="0">
+          <a:bodyPr wrap="square" lIns="0" tIns="0" rIns="0" bIns="0" anchor="t">
             <a:spAutoFit/>
           </a:bodyPr>
           <a:lstStyle/>
@@ -10188,17 +10339,17 @@
       </p:sp>
     </p:spTree>
   </p:cSld>
+  <p:clrMapOvr>
+    <a:masterClrMapping/>
+  </p:clrMapOvr>
   <p:transition spd="med">
     <p:cover dir="u"/>
   </p:transition>
-  <p:clrMapOvr>
-    <a:masterClrMapping/>
-  </p:clrMapOvr>
 </p:sld>
 </file>
 
 <file path=ppt/slides/slide5.xml><?xml version="1.0" encoding="utf-8"?>
-<p:sld xmlns:a="http://schemas.openxmlformats.org/drawingml/2006/main" xmlns:p="http://schemas.openxmlformats.org/presentationml/2006/main" xmlns:r="http://schemas.openxmlformats.org/officeDocument/2006/relationships">
+<p:sld xmlns:a="http://schemas.openxmlformats.org/drawingml/2006/main" xmlns:r="http://schemas.openxmlformats.org/officeDocument/2006/relationships" xmlns:p="http://schemas.openxmlformats.org/presentationml/2006/main">
   <p:cSld>
     <p:spTree>
       <p:nvGrpSpPr>
@@ -10206,7 +10357,14 @@
         <p:cNvGrpSpPr/>
         <p:nvPr/>
       </p:nvGrpSpPr>
-      <p:grpSpPr/>
+      <p:grpSpPr>
+        <a:xfrm>
+          <a:off x="0" y="0"/>
+          <a:ext cx="0" cy="0"/>
+          <a:chOff x="0" y="0"/>
+          <a:chExt cx="0" cy="0"/>
+        </a:xfrm>
+      </p:grpSpPr>
       <p:sp>
         <p:nvSpPr>
           <p:cNvPr id="2" name="BGPlate"/>
@@ -10230,7 +10388,7 @@
                 <a:srgbClr val="3B1F7A"/>
               </a:gs>
             </a:gsLst>
-            <a:lin scaled="0" ang="14400000"/>
+            <a:lin ang="14400000" scaled="0"/>
           </a:gradFill>
           <a:ln>
             <a:noFill/>
@@ -10256,6 +10414,7 @@
           <a:lstStyle/>
           <a:p>
             <a:pPr algn="ctr"/>
+            <a:endParaRPr/>
           </a:p>
         </p:txBody>
       </p:sp>
@@ -10302,6 +10461,7 @@
           <a:lstStyle/>
           <a:p>
             <a:pPr algn="ctr"/>
+            <a:endParaRPr dirty="0"/>
           </a:p>
         </p:txBody>
       </p:sp>
@@ -10348,6 +10508,7 @@
           <a:lstStyle/>
           <a:p>
             <a:pPr algn="ctr"/>
+            <a:endParaRPr/>
           </a:p>
         </p:txBody>
       </p:sp>
@@ -10394,6 +10555,7 @@
           <a:lstStyle/>
           <a:p>
             <a:pPr algn="ctr"/>
+            <a:endParaRPr/>
           </a:p>
         </p:txBody>
       </p:sp>
@@ -10405,7 +10567,7 @@
         </p:nvSpPr>
         <p:spPr>
           <a:xfrm>
-            <a:off x="5376672" y="-475488"/>
+            <a:off x="5193792" y="-475488"/>
             <a:ext cx="1316736" cy="1316736"/>
           </a:xfrm>
           <a:prstGeom prst="ellipse">
@@ -10440,6 +10602,7 @@
           <a:lstStyle/>
           <a:p>
             <a:pPr algn="ctr"/>
+            <a:endParaRPr/>
           </a:p>
         </p:txBody>
       </p:sp>
@@ -10451,7 +10614,7 @@
         </p:nvSpPr>
         <p:spPr>
           <a:xfrm>
-            <a:off x="640080" y="384048"/>
+            <a:off x="640080" y="484632"/>
             <a:ext cx="9601200" cy="365760"/>
           </a:xfrm>
           <a:prstGeom prst="rect">
@@ -10460,7 +10623,7 @@
           <a:noFill/>
         </p:spPr>
         <p:txBody>
-          <a:bodyPr wrap="square" anchor="t" lIns="0" rIns="0" tIns="0" bIns="0">
+          <a:bodyPr wrap="square" lIns="0" tIns="0" rIns="0" bIns="0" anchor="t">
             <a:spAutoFit/>
           </a:bodyPr>
           <a:lstStyle/>
@@ -10495,7 +10658,7 @@
           <a:noFill/>
         </p:spPr>
         <p:txBody>
-          <a:bodyPr wrap="square" anchor="t" lIns="0" rIns="0" tIns="0" bIns="0">
+          <a:bodyPr wrap="square" lIns="0" tIns="0" rIns="0" bIns="0" anchor="t">
             <a:spAutoFit/>
           </a:bodyPr>
           <a:lstStyle/>
@@ -10531,19 +10694,6 @@
             <a:noFill/>
           </a:ln>
           <a:effectLst/>
-          <a:gradFill rotWithShape="1">
-            <a:gsLst>
-              <a:gs pos="0">
-                <a:srgbClr val="B497CF"/>
-              </a:gs>
-              <a:gs pos="100000">
-                <a:srgbClr val="B497CF">
-                  <a:alpha val="0"/>
-                </a:srgbClr>
-              </a:gs>
-            </a:gsLst>
-            <a:lin ang="0" scaled="1"/>
-          </a:gradFill>
         </p:spPr>
         <p:style>
           <a:lnRef idx="1">
@@ -10564,6 +10714,7 @@
           <a:lstStyle/>
           <a:p>
             <a:pPr algn="ctr"/>
+            <a:endParaRPr/>
           </a:p>
         </p:txBody>
       </p:sp>
@@ -10614,6 +10765,7 @@
           <a:lstStyle/>
           <a:p>
             <a:pPr algn="ctr"/>
+            <a:endParaRPr/>
           </a:p>
         </p:txBody>
       </p:sp>
@@ -10634,7 +10786,7 @@
           <a:noFill/>
         </p:spPr>
         <p:txBody>
-          <a:bodyPr wrap="square" anchor="t" lIns="0" rIns="0" tIns="0" bIns="0">
+          <a:bodyPr wrap="square" lIns="0" tIns="0" rIns="0" bIns="0" anchor="t">
             <a:spAutoFit/>
           </a:bodyPr>
           <a:lstStyle/>
@@ -10671,7 +10823,7 @@
           <a:noFill/>
         </p:spPr>
         <p:txBody>
-          <a:bodyPr wrap="square" anchor="t" lIns="0" rIns="0" tIns="0" bIns="0">
+          <a:bodyPr wrap="square" lIns="0" tIns="0" rIns="0" bIns="0" anchor="t">
             <a:spAutoFit/>
           </a:bodyPr>
           <a:lstStyle/>
@@ -10740,6 +10892,7 @@
           <a:lstStyle/>
           <a:p>
             <a:pPr algn="ctr"/>
+            <a:endParaRPr/>
           </a:p>
         </p:txBody>
       </p:sp>
@@ -10768,7 +10921,7 @@
                 <a:srgbClr val="8B85FF"/>
               </a:gs>
             </a:gsLst>
-            <a:lin scaled="0" ang="0"/>
+            <a:lin ang="0" scaled="0"/>
           </a:gradFill>
           <a:ln>
             <a:noFill/>
@@ -10794,6 +10947,7 @@
           <a:lstStyle/>
           <a:p>
             <a:pPr algn="ctr"/>
+            <a:endParaRPr/>
           </a:p>
         </p:txBody>
       </p:sp>
@@ -10814,14 +10968,14 @@
           <a:noFill/>
         </p:spPr>
         <p:txBody>
-          <a:bodyPr wrap="square" anchor="t" lIns="0" rIns="0" tIns="0" bIns="0">
+          <a:bodyPr wrap="square" lIns="0" tIns="0" rIns="0" bIns="0" anchor="t">
             <a:spAutoFit/>
           </a:bodyPr>
           <a:lstStyle/>
           <a:p>
             <a:pPr algn="l"/>
             <a:r>
-              <a:rPr sz="1050" b="0" i="1">
+              <a:rPr sz="1050" b="0" i="1" dirty="0">
                 <a:solidFill>
                   <a:srgbClr val="FFFFFF">
                     <a:alpha val="55000"/>
@@ -10881,6 +11035,7 @@
           <a:lstStyle/>
           <a:p>
             <a:pPr algn="ctr"/>
+            <a:endParaRPr/>
           </a:p>
         </p:txBody>
       </p:sp>
@@ -10901,7 +11056,7 @@
           <a:noFill/>
         </p:spPr>
         <p:txBody>
-          <a:bodyPr wrap="square" anchor="t" lIns="0" rIns="0" tIns="0" bIns="0">
+          <a:bodyPr wrap="square" lIns="0" tIns="0" rIns="0" bIns="0" anchor="t">
             <a:spAutoFit/>
           </a:bodyPr>
           <a:lstStyle/>
@@ -10936,7 +11091,7 @@
           <a:noFill/>
         </p:spPr>
         <p:txBody>
-          <a:bodyPr wrap="square" anchor="t" lIns="0" rIns="0" tIns="0" bIns="0">
+          <a:bodyPr wrap="square" lIns="0" tIns="0" rIns="0" bIns="0" anchor="t">
             <a:spAutoFit/>
           </a:bodyPr>
           <a:lstStyle/>
@@ -10975,7 +11130,7 @@
           <a:noFill/>
         </p:spPr>
         <p:txBody>
-          <a:bodyPr wrap="square" anchor="t" lIns="0" rIns="0" tIns="0" bIns="0">
+          <a:bodyPr wrap="square" lIns="0" tIns="0" rIns="0" bIns="0" anchor="t">
             <a:spAutoFit/>
           </a:bodyPr>
           <a:lstStyle/>
@@ -11040,6 +11195,7 @@
           <a:lstStyle/>
           <a:p>
             <a:pPr algn="ctr"/>
+            <a:endParaRPr/>
           </a:p>
         </p:txBody>
       </p:sp>
@@ -11088,6 +11244,7 @@
           <a:lstStyle/>
           <a:p>
             <a:pPr algn="ctr"/>
+            <a:endParaRPr/>
           </a:p>
         </p:txBody>
       </p:sp>
@@ -11108,7 +11265,7 @@
           <a:noFill/>
         </p:spPr>
         <p:txBody>
-          <a:bodyPr wrap="square" anchor="t" lIns="0" rIns="0" tIns="0" bIns="0">
+          <a:bodyPr wrap="square" lIns="0" tIns="0" rIns="0" bIns="0" anchor="t">
             <a:spAutoFit/>
           </a:bodyPr>
           <a:lstStyle/>
@@ -11143,7 +11300,7 @@
           <a:noFill/>
         </p:spPr>
         <p:txBody>
-          <a:bodyPr wrap="square" anchor="t" lIns="0" rIns="0" tIns="0" bIns="0">
+          <a:bodyPr wrap="square" lIns="0" tIns="0" rIns="0" bIns="0" anchor="t">
             <a:spAutoFit/>
           </a:bodyPr>
           <a:lstStyle/>
@@ -11178,7 +11335,7 @@
           <a:noFill/>
         </p:spPr>
         <p:txBody>
-          <a:bodyPr wrap="square" anchor="t" lIns="0" rIns="0" tIns="0" bIns="0">
+          <a:bodyPr wrap="square" lIns="0" tIns="0" rIns="0" bIns="0" anchor="t">
             <a:spAutoFit/>
           </a:bodyPr>
           <a:lstStyle/>
@@ -11213,7 +11370,7 @@
           <a:noFill/>
         </p:spPr>
         <p:txBody>
-          <a:bodyPr wrap="square" anchor="t" lIns="0" rIns="0" tIns="0" bIns="0">
+          <a:bodyPr wrap="square" lIns="0" tIns="0" rIns="0" bIns="0" anchor="t">
             <a:spAutoFit/>
           </a:bodyPr>
           <a:lstStyle/>
@@ -11254,7 +11411,7 @@
           <a:noFill/>
         </p:spPr>
         <p:txBody>
-          <a:bodyPr wrap="square" anchor="t" lIns="0" rIns="0" tIns="0" bIns="0">
+          <a:bodyPr wrap="square" lIns="0" tIns="0" rIns="0" bIns="0" anchor="t">
             <a:spAutoFit/>
           </a:bodyPr>
           <a:lstStyle/>
@@ -11289,7 +11446,7 @@
           <a:noFill/>
         </p:spPr>
         <p:txBody>
-          <a:bodyPr wrap="square" anchor="t" lIns="0" rIns="0" tIns="0" bIns="0">
+          <a:bodyPr wrap="square" lIns="0" tIns="0" rIns="0" bIns="0" anchor="t">
             <a:spAutoFit/>
           </a:bodyPr>
           <a:lstStyle/>
@@ -11330,7 +11487,7 @@
           <a:noFill/>
         </p:spPr>
         <p:txBody>
-          <a:bodyPr wrap="square" anchor="t" lIns="0" rIns="0" tIns="0" bIns="0">
+          <a:bodyPr wrap="square" lIns="0" tIns="0" rIns="0" bIns="0" anchor="t">
             <a:spAutoFit/>
           </a:bodyPr>
           <a:lstStyle/>
@@ -11365,7 +11522,7 @@
           <a:noFill/>
         </p:spPr>
         <p:txBody>
-          <a:bodyPr wrap="square" anchor="t" lIns="0" rIns="0" tIns="0" bIns="0">
+          <a:bodyPr wrap="square" lIns="0" tIns="0" rIns="0" bIns="0" anchor="t">
             <a:spAutoFit/>
           </a:bodyPr>
           <a:lstStyle/>
@@ -11406,7 +11563,7 @@
           <a:noFill/>
         </p:spPr>
         <p:txBody>
-          <a:bodyPr wrap="square" anchor="t" lIns="0" rIns="0" tIns="0" bIns="0">
+          <a:bodyPr wrap="square" lIns="0" tIns="0" rIns="0" bIns="0" anchor="t">
             <a:spAutoFit/>
           </a:bodyPr>
           <a:lstStyle/>
@@ -11443,7 +11600,7 @@
           <a:noFill/>
         </p:spPr>
         <p:txBody>
-          <a:bodyPr wrap="square" anchor="t" lIns="0" rIns="0" tIns="0" bIns="0">
+          <a:bodyPr wrap="square" lIns="0" tIns="0" rIns="0" bIns="0" anchor="t">
             <a:spAutoFit/>
           </a:bodyPr>
           <a:lstStyle/>
@@ -11465,17 +11622,17 @@
       </p:sp>
     </p:spTree>
   </p:cSld>
-  <p:transition spd="slow">
-    <p:fade thruBlk="0"/>
-  </p:transition>
   <p:clrMapOvr>
     <a:masterClrMapping/>
   </p:clrMapOvr>
+  <p:transition spd="slow">
+    <p:fade/>
+  </p:transition>
 </p:sld>
 </file>
 
 <file path=ppt/slides/slide6.xml><?xml version="1.0" encoding="utf-8"?>
-<p:sld xmlns:a="http://schemas.openxmlformats.org/drawingml/2006/main" xmlns:p="http://schemas.openxmlformats.org/presentationml/2006/main" xmlns:r="http://schemas.openxmlformats.org/officeDocument/2006/relationships">
+<p:sld xmlns:a="http://schemas.openxmlformats.org/drawingml/2006/main" xmlns:r="http://schemas.openxmlformats.org/officeDocument/2006/relationships" xmlns:p="http://schemas.openxmlformats.org/presentationml/2006/main">
   <p:cSld>
     <p:spTree>
       <p:nvGrpSpPr>
@@ -11483,7 +11640,14 @@
         <p:cNvGrpSpPr/>
         <p:nvPr/>
       </p:nvGrpSpPr>
-      <p:grpSpPr/>
+      <p:grpSpPr>
+        <a:xfrm>
+          <a:off x="0" y="0"/>
+          <a:ext cx="0" cy="0"/>
+          <a:chOff x="0" y="0"/>
+          <a:chExt cx="0" cy="0"/>
+        </a:xfrm>
+      </p:grpSpPr>
       <p:sp>
         <p:nvSpPr>
           <p:cNvPr id="2" name="BGPlate"/>
@@ -11507,7 +11671,7 @@
                 <a:srgbClr val="3B1F7A"/>
               </a:gs>
             </a:gsLst>
-            <a:lin scaled="0" ang="15000000"/>
+            <a:lin ang="15000000" scaled="0"/>
           </a:gradFill>
           <a:ln>
             <a:noFill/>
@@ -11533,6 +11697,7 @@
           <a:lstStyle/>
           <a:p>
             <a:pPr algn="ctr"/>
+            <a:endParaRPr/>
           </a:p>
         </p:txBody>
       </p:sp>
@@ -11579,6 +11744,7 @@
           <a:lstStyle/>
           <a:p>
             <a:pPr algn="ctr"/>
+            <a:endParaRPr/>
           </a:p>
         </p:txBody>
       </p:sp>
@@ -11625,6 +11791,7 @@
           <a:lstStyle/>
           <a:p>
             <a:pPr algn="ctr"/>
+            <a:endParaRPr/>
           </a:p>
         </p:txBody>
       </p:sp>
@@ -11671,6 +11838,7 @@
           <a:lstStyle/>
           <a:p>
             <a:pPr algn="ctr"/>
+            <a:endParaRPr/>
           </a:p>
         </p:txBody>
       </p:sp>
@@ -11717,6 +11885,7 @@
           <a:lstStyle/>
           <a:p>
             <a:pPr algn="ctr"/>
+            <a:endParaRPr/>
           </a:p>
         </p:txBody>
       </p:sp>
@@ -11737,7 +11906,7 @@
           <a:noFill/>
         </p:spPr>
         <p:txBody>
-          <a:bodyPr wrap="square" anchor="t" lIns="0" rIns="0" tIns="0" bIns="0">
+          <a:bodyPr wrap="square" lIns="0" tIns="0" rIns="0" bIns="0" anchor="t">
             <a:spAutoFit/>
           </a:bodyPr>
           <a:lstStyle/>
@@ -11772,7 +11941,7 @@
           <a:noFill/>
         </p:spPr>
         <p:txBody>
-          <a:bodyPr wrap="square" anchor="t" lIns="0" rIns="0" tIns="0" bIns="0">
+          <a:bodyPr wrap="square" lIns="0" tIns="0" rIns="0" bIns="0" anchor="t">
             <a:spAutoFit/>
           </a:bodyPr>
           <a:lstStyle/>
@@ -11808,19 +11977,6 @@
             <a:noFill/>
           </a:ln>
           <a:effectLst/>
-          <a:gradFill rotWithShape="1">
-            <a:gsLst>
-              <a:gs pos="0">
-                <a:srgbClr val="B497CF"/>
-              </a:gs>
-              <a:gs pos="100000">
-                <a:srgbClr val="B497CF">
-                  <a:alpha val="0"/>
-                </a:srgbClr>
-              </a:gs>
-            </a:gsLst>
-            <a:lin ang="0" scaled="1"/>
-          </a:gradFill>
         </p:spPr>
         <p:style>
           <a:lnRef idx="1">
@@ -11841,6 +11997,7 @@
           <a:lstStyle/>
           <a:p>
             <a:pPr algn="ctr"/>
+            <a:endParaRPr/>
           </a:p>
         </p:txBody>
       </p:sp>
@@ -11891,6 +12048,7 @@
           <a:lstStyle/>
           <a:p>
             <a:pPr algn="ctr"/>
+            <a:endParaRPr/>
           </a:p>
         </p:txBody>
       </p:sp>
@@ -11911,7 +12069,7 @@
           <a:noFill/>
         </p:spPr>
         <p:txBody>
-          <a:bodyPr wrap="square" anchor="ctr" lIns="0" rIns="0" tIns="0" bIns="0">
+          <a:bodyPr wrap="square" lIns="0" tIns="0" rIns="0" bIns="0" anchor="ctr">
             <a:spAutoFit/>
           </a:bodyPr>
           <a:lstStyle/>
@@ -11946,7 +12104,7 @@
           <a:noFill/>
         </p:spPr>
         <p:txBody>
-          <a:bodyPr wrap="square" anchor="t" lIns="0" rIns="0" tIns="0" bIns="0">
+          <a:bodyPr wrap="square" lIns="0" tIns="0" rIns="0" bIns="0" anchor="t">
             <a:spAutoFit/>
           </a:bodyPr>
           <a:lstStyle/>
@@ -12017,6 +12175,7 @@
           <a:lstStyle/>
           <a:p>
             <a:pPr algn="ctr"/>
+            <a:endParaRPr/>
           </a:p>
         </p:txBody>
       </p:sp>
@@ -12037,7 +12196,7 @@
           <a:noFill/>
         </p:spPr>
         <p:txBody>
-          <a:bodyPr wrap="square" anchor="ctr" lIns="0" rIns="0" tIns="0" bIns="0">
+          <a:bodyPr wrap="square" lIns="0" tIns="0" rIns="0" bIns="0" anchor="ctr">
             <a:spAutoFit/>
           </a:bodyPr>
           <a:lstStyle/>
@@ -12072,7 +12231,7 @@
           <a:noFill/>
         </p:spPr>
         <p:txBody>
-          <a:bodyPr wrap="square" anchor="t" lIns="0" rIns="0" tIns="0" bIns="0">
+          <a:bodyPr wrap="square" lIns="0" tIns="0" rIns="0" bIns="0" anchor="t">
             <a:spAutoFit/>
           </a:bodyPr>
           <a:lstStyle/>
@@ -12143,6 +12302,7 @@
           <a:lstStyle/>
           <a:p>
             <a:pPr algn="ctr"/>
+            <a:endParaRPr/>
           </a:p>
         </p:txBody>
       </p:sp>
@@ -12163,7 +12323,7 @@
           <a:noFill/>
         </p:spPr>
         <p:txBody>
-          <a:bodyPr wrap="square" anchor="ctr" lIns="0" rIns="0" tIns="0" bIns="0">
+          <a:bodyPr wrap="square" lIns="0" tIns="0" rIns="0" bIns="0" anchor="ctr">
             <a:spAutoFit/>
           </a:bodyPr>
           <a:lstStyle/>
@@ -12198,7 +12358,7 @@
           <a:noFill/>
         </p:spPr>
         <p:txBody>
-          <a:bodyPr wrap="square" anchor="t" lIns="0" rIns="0" tIns="0" bIns="0">
+          <a:bodyPr wrap="square" lIns="0" tIns="0" rIns="0" bIns="0" anchor="t">
             <a:spAutoFit/>
           </a:bodyPr>
           <a:lstStyle/>
@@ -12269,6 +12429,7 @@
           <a:lstStyle/>
           <a:p>
             <a:pPr algn="ctr"/>
+            <a:endParaRPr/>
           </a:p>
         </p:txBody>
       </p:sp>
@@ -12280,8 +12441,8 @@
         </p:nvSpPr>
         <p:spPr>
           <a:xfrm>
-            <a:off x="640080" y="4169663"/>
-            <a:ext cx="347472" cy="347472"/>
+            <a:off x="640080" y="4251066"/>
+            <a:ext cx="347472" cy="184666"/>
           </a:xfrm>
           <a:prstGeom prst="rect">
             <a:avLst/>
@@ -12289,7 +12450,7 @@
           <a:noFill/>
         </p:spPr>
         <p:txBody>
-          <a:bodyPr wrap="square" anchor="ctr" lIns="0" rIns="0" tIns="0" bIns="0">
+          <a:bodyPr wrap="square" lIns="0" tIns="0" rIns="0" bIns="0" anchor="ctr">
             <a:spAutoFit/>
           </a:bodyPr>
           <a:lstStyle/>
@@ -12316,7 +12477,7 @@
         <p:spPr>
           <a:xfrm>
             <a:off x="1170432" y="4178807"/>
-            <a:ext cx="9966960" cy="594360"/>
+            <a:ext cx="9966960" cy="390300"/>
           </a:xfrm>
           <a:prstGeom prst="rect">
             <a:avLst/>
@@ -12324,7 +12485,7 @@
           <a:noFill/>
         </p:spPr>
         <p:txBody>
-          <a:bodyPr wrap="square" anchor="t" lIns="0" rIns="0" tIns="0" bIns="0">
+          <a:bodyPr wrap="square" lIns="0" tIns="0" rIns="0" bIns="0" anchor="t">
             <a:spAutoFit/>
           </a:bodyPr>
           <a:lstStyle/>
@@ -12335,7 +12496,7 @@
               </a:lnSpc>
             </a:pPr>
             <a:r>
-              <a:rPr sz="1200" b="0" i="0">
+              <a:rPr sz="1200" b="0" i="0" dirty="0">
                 <a:solidFill>
                   <a:srgbClr val="FFFFFF">
                     <a:alpha val="85000"/>
@@ -12345,6 +12506,29 @@
               </a:rPr>
               <a:t>Positioning: Classroom/Moodle track endpoints only; Duolingo-style apps gamify without institutional visibility — Avance sits in the gap.</a:t>
             </a:r>
+            <a:endParaRPr lang="en-IN" sz="1200" b="0" i="0" dirty="0">
+              <a:solidFill>
+                <a:srgbClr val="FFFFFF">
+                  <a:alpha val="85000"/>
+                </a:srgbClr>
+              </a:solidFill>
+              <a:latin typeface="Segoe UI"/>
+            </a:endParaRPr>
+          </a:p>
+          <a:p>
+            <a:pPr algn="l">
+              <a:lnSpc>
+                <a:spcPct val="110000"/>
+              </a:lnSpc>
+            </a:pPr>
+            <a:endParaRPr sz="1200" b="0" i="0" dirty="0">
+              <a:solidFill>
+                <a:srgbClr val="FFFFFF">
+                  <a:alpha val="85000"/>
+                </a:srgbClr>
+              </a:solidFill>
+              <a:latin typeface="Segoe UI"/>
+            </a:endParaRPr>
           </a:p>
         </p:txBody>
       </p:sp>
@@ -12395,6 +12579,7 @@
           <a:lstStyle/>
           <a:p>
             <a:pPr algn="ctr"/>
+            <a:endParaRPr/>
           </a:p>
         </p:txBody>
       </p:sp>
@@ -12415,7 +12600,7 @@
           <a:noFill/>
         </p:spPr>
         <p:txBody>
-          <a:bodyPr wrap="square" anchor="t" lIns="0" rIns="0" tIns="0" bIns="0">
+          <a:bodyPr wrap="square" lIns="0" tIns="0" rIns="0" bIns="0" anchor="t">
             <a:spAutoFit/>
           </a:bodyPr>
           <a:lstStyle/>
@@ -12450,7 +12635,7 @@
           <a:noFill/>
         </p:spPr>
         <p:txBody>
-          <a:bodyPr wrap="square" anchor="t" lIns="0" rIns="0" tIns="0" bIns="0">
+          <a:bodyPr wrap="square" lIns="0" tIns="0" rIns="0" bIns="0" anchor="t">
             <a:spAutoFit/>
           </a:bodyPr>
           <a:lstStyle/>
@@ -12489,7 +12674,7 @@
           <a:noFill/>
         </p:spPr>
         <p:txBody>
-          <a:bodyPr wrap="square" anchor="ctr" lIns="0" rIns="0" tIns="0" bIns="0">
+          <a:bodyPr wrap="square" lIns="0" tIns="0" rIns="0" bIns="0" anchor="ctr">
             <a:spAutoFit/>
           </a:bodyPr>
           <a:lstStyle/>
@@ -12524,7 +12709,7 @@
           <a:noFill/>
         </p:spPr>
         <p:txBody>
-          <a:bodyPr wrap="square" anchor="ctr" lIns="0" rIns="0" tIns="0" bIns="0">
+          <a:bodyPr wrap="square" lIns="0" tIns="0" rIns="0" bIns="0" anchor="ctr">
             <a:spAutoFit/>
           </a:bodyPr>
           <a:lstStyle/>
@@ -12559,7 +12744,7 @@
           <a:noFill/>
         </p:spPr>
         <p:txBody>
-          <a:bodyPr wrap="square" anchor="t" lIns="0" rIns="0" tIns="0" bIns="0">
+          <a:bodyPr wrap="square" lIns="0" tIns="0" rIns="0" bIns="0" anchor="t">
             <a:spAutoFit/>
           </a:bodyPr>
           <a:lstStyle/>
@@ -12596,7 +12781,7 @@
           <a:noFill/>
         </p:spPr>
         <p:txBody>
-          <a:bodyPr wrap="square" anchor="t" lIns="0" rIns="0" tIns="0" bIns="0">
+          <a:bodyPr wrap="square" lIns="0" tIns="0" rIns="0" bIns="0" anchor="t">
             <a:spAutoFit/>
           </a:bodyPr>
           <a:lstStyle/>

</xml_diff>

<commit_message>
Add audio cue sheet and mixing script; implement AI-driven quest builder
- Created `audio-cues.html` to define audio cues for the project, including music and sound effects with specified timings and volumes.
- Developed `mix-audio.py` to automate the mixing of audio cues into a single track using FFmpeg, improving performance by reducing the number of audio sources.
- Introduced `aiQuestBuilder.ts` to leverage the Anthropic AI model for generating quest proposals based on assignment inputs, enhancing the quest creation process with AI assistance.
</commit_message>
<xml_diff>
--- a/sih-pitch/Avance_SIH26207_Pitch_v2.pptx
+++ b/sih-pitch/Avance_SIH26207_Pitch_v2.pptx
@@ -313,7 +313,7 @@
           <a:p>
             <a:fld id="{5BCAD085-E8A6-8845-BD4E-CB4CCA059FC4}" type="datetimeFigureOut">
               <a:rPr lang="en-US" smtClean="0"/>
-              <a:t>9/13/2026</a:t>
+              <a:t>9/15/2026</a:t>
             </a:fld>
             <a:endParaRPr lang="en-US"/>
           </a:p>
@@ -481,7 +481,7 @@
           <a:p>
             <a:fld id="{5BCAD085-E8A6-8845-BD4E-CB4CCA059FC4}" type="datetimeFigureOut">
               <a:rPr lang="en-US" smtClean="0"/>
-              <a:t>9/13/2026</a:t>
+              <a:t>9/15/2026</a:t>
             </a:fld>
             <a:endParaRPr lang="en-US"/>
           </a:p>
@@ -659,7 +659,7 @@
           <a:p>
             <a:fld id="{5BCAD085-E8A6-8845-BD4E-CB4CCA059FC4}" type="datetimeFigureOut">
               <a:rPr lang="en-US" smtClean="0"/>
-              <a:t>9/13/2026</a:t>
+              <a:t>9/15/2026</a:t>
             </a:fld>
             <a:endParaRPr lang="en-US"/>
           </a:p>
@@ -827,7 +827,7 @@
           <a:p>
             <a:fld id="{5BCAD085-E8A6-8845-BD4E-CB4CCA059FC4}" type="datetimeFigureOut">
               <a:rPr lang="en-US" smtClean="0"/>
-              <a:t>9/13/2026</a:t>
+              <a:t>9/15/2026</a:t>
             </a:fld>
             <a:endParaRPr lang="en-US"/>
           </a:p>
@@ -1072,7 +1072,7 @@
           <a:p>
             <a:fld id="{5BCAD085-E8A6-8845-BD4E-CB4CCA059FC4}" type="datetimeFigureOut">
               <a:rPr lang="en-US" smtClean="0"/>
-              <a:t>9/13/2026</a:t>
+              <a:t>9/15/2026</a:t>
             </a:fld>
             <a:endParaRPr lang="en-US"/>
           </a:p>
@@ -1357,7 +1357,7 @@
           <a:p>
             <a:fld id="{5BCAD085-E8A6-8845-BD4E-CB4CCA059FC4}" type="datetimeFigureOut">
               <a:rPr lang="en-US" smtClean="0"/>
-              <a:t>9/13/2026</a:t>
+              <a:t>9/15/2026</a:t>
             </a:fld>
             <a:endParaRPr lang="en-US"/>
           </a:p>
@@ -1776,7 +1776,7 @@
           <a:p>
             <a:fld id="{5BCAD085-E8A6-8845-BD4E-CB4CCA059FC4}" type="datetimeFigureOut">
               <a:rPr lang="en-US" smtClean="0"/>
-              <a:t>9/13/2026</a:t>
+              <a:t>9/15/2026</a:t>
             </a:fld>
             <a:endParaRPr lang="en-US"/>
           </a:p>
@@ -1893,7 +1893,7 @@
           <a:p>
             <a:fld id="{5BCAD085-E8A6-8845-BD4E-CB4CCA059FC4}" type="datetimeFigureOut">
               <a:rPr lang="en-US" smtClean="0"/>
-              <a:t>9/13/2026</a:t>
+              <a:t>9/15/2026</a:t>
             </a:fld>
             <a:endParaRPr lang="en-US"/>
           </a:p>
@@ -1988,7 +1988,7 @@
           <a:p>
             <a:fld id="{5BCAD085-E8A6-8845-BD4E-CB4CCA059FC4}" type="datetimeFigureOut">
               <a:rPr lang="en-US" smtClean="0"/>
-              <a:t>9/13/2026</a:t>
+              <a:t>9/15/2026</a:t>
             </a:fld>
             <a:endParaRPr lang="en-US"/>
           </a:p>
@@ -2263,7 +2263,7 @@
           <a:p>
             <a:fld id="{5BCAD085-E8A6-8845-BD4E-CB4CCA059FC4}" type="datetimeFigureOut">
               <a:rPr lang="en-US" smtClean="0"/>
-              <a:t>9/13/2026</a:t>
+              <a:t>9/15/2026</a:t>
             </a:fld>
             <a:endParaRPr lang="en-US"/>
           </a:p>
@@ -2515,7 +2515,7 @@
           <a:p>
             <a:fld id="{5BCAD085-E8A6-8845-BD4E-CB4CCA059FC4}" type="datetimeFigureOut">
               <a:rPr lang="en-US" smtClean="0"/>
-              <a:t>9/13/2026</a:t>
+              <a:t>9/15/2026</a:t>
             </a:fld>
             <a:endParaRPr lang="en-US"/>
           </a:p>
@@ -2729,7 +2729,7 @@
           <a:p>
             <a:fld id="{5BCAD085-E8A6-8845-BD4E-CB4CCA059FC4}" type="datetimeFigureOut">
               <a:rPr lang="en-US" smtClean="0"/>
-              <a:t>9/13/2026</a:t>
+              <a:t>9/15/2026</a:t>
             </a:fld>
             <a:endParaRPr lang="en-US"/>
           </a:p>
@@ -3112,7 +3112,7 @@
         </p:nvSpPr>
         <p:spPr>
           <a:xfrm>
-            <a:off x="446650" y="1143000"/>
+            <a:off x="0" y="-91440"/>
             <a:ext cx="12280392" cy="6949440"/>
           </a:xfrm>
           <a:prstGeom prst="rect">
@@ -3400,7 +3400,7 @@
         </p:nvSpPr>
         <p:spPr>
           <a:xfrm>
-            <a:off x="212140" y="4418380"/>
+            <a:off x="326441" y="4447642"/>
             <a:ext cx="3233318" cy="3233318"/>
           </a:xfrm>
           <a:prstGeom prst="ellipse">
@@ -3665,7 +3665,7 @@
         <p:spPr>
           <a:xfrm>
             <a:off x="603504" y="1874519"/>
-            <a:ext cx="10881360" cy="1463040"/>
+            <a:ext cx="10881360" cy="1415772"/>
           </a:xfrm>
           <a:prstGeom prst="rect">
             <a:avLst/>
@@ -3684,10 +3684,17 @@
                 <a:solidFill>
                   <a:srgbClr val="FFFFFF"/>
                 </a:solidFill>
-                <a:latin typeface="Segoe UI"/>
+                <a:latin typeface="Poor Richard" panose="02080502050505020702" pitchFamily="18" charset="0"/>
               </a:rPr>
               <a:t>AVANCE</a:t>
             </a:r>
+            <a:endParaRPr lang="en-IN" sz="9200" b="1" i="0" dirty="0">
+              <a:solidFill>
+                <a:srgbClr val="FFFFFF"/>
+              </a:solidFill>
+              <a:latin typeface="Poor Richard" panose="02080502050505020702" pitchFamily="18" charset="0"/>
+              <a:ea typeface="PMingLiU-ExtB" panose="02020500000000000000" pitchFamily="18" charset="-120"/>
+            </a:endParaRPr>
           </a:p>
         </p:txBody>
       </p:sp>
@@ -3735,7 +3742,7 @@
         <p:spPr>
           <a:xfrm>
             <a:off x="640080" y="4096512"/>
-            <a:ext cx="9875520" cy="914400"/>
+            <a:ext cx="9875520" cy="461665"/>
           </a:xfrm>
           <a:prstGeom prst="rect">
             <a:avLst/>
@@ -3758,7 +3765,18 @@
                 </a:solidFill>
                 <a:latin typeface="Segoe UI"/>
               </a:rPr>
-              <a:t>“Smart Education — a concept that describes learning in the digital age; helping learners learn more efficiently, effectively, flexibly and comfortably.”</a:t>
+              <a:t>“</a:t>
+            </a:r>
+            <a:r>
+              <a:rPr sz="1500" b="0" i="1" dirty="0">
+                <a:solidFill>
+                  <a:srgbClr val="FFFFFF">
+                    <a:alpha val="62000"/>
+                  </a:srgbClr>
+                </a:solidFill>
+                <a:latin typeface="Segoe UI"/>
+              </a:rPr>
+              <a:t>Smart Education — a concept that describes learning in the digital age; helping learners learn more efficiently, effectively, flexibly and comfortably.”</a:t>
             </a:r>
           </a:p>
         </p:txBody>
@@ -3854,7 +3872,7 @@
         <p:spPr>
           <a:xfrm>
             <a:off x="640080" y="5623560"/>
-            <a:ext cx="2606040" cy="200055"/>
+            <a:ext cx="2606040" cy="307777"/>
           </a:xfrm>
           <a:prstGeom prst="rect">
             <a:avLst/>
@@ -3869,23 +3887,23 @@
           <a:p>
             <a:pPr algn="l"/>
             <a:r>
-              <a:rPr lang="en-IN" sz="1300" b="0" i="0" dirty="0">
+              <a:rPr lang="en-IN" sz="2000" b="0" i="0" dirty="0">
                 <a:solidFill>
                   <a:srgbClr val="FFFFFF">
                     <a:alpha val="90000"/>
                   </a:srgbClr>
                 </a:solidFill>
-                <a:latin typeface="Segoe UI"/>
+                <a:latin typeface="Consolas" panose="020B0609020204030204" pitchFamily="49" charset="0"/>
               </a:rPr>
               <a:t>Avance</a:t>
             </a:r>
-            <a:endParaRPr sz="1300" b="0" i="0" dirty="0">
+            <a:endParaRPr sz="2000" b="0" i="0" dirty="0">
               <a:solidFill>
                 <a:srgbClr val="FFFFFF">
                   <a:alpha val="90000"/>
                 </a:srgbClr>
               </a:solidFill>
-              <a:latin typeface="Segoe UI"/>
+              <a:latin typeface="Consolas" panose="020B0609020204030204" pitchFamily="49" charset="0"/>
             </a:endParaRPr>
           </a:p>
         </p:txBody>
@@ -3933,8 +3951,8 @@
         </p:nvSpPr>
         <p:spPr>
           <a:xfrm>
-            <a:off x="3337560" y="5623560"/>
-            <a:ext cx="2606040" cy="400110"/>
+            <a:off x="2903220" y="5645102"/>
+            <a:ext cx="2606040" cy="461665"/>
           </a:xfrm>
           <a:prstGeom prst="rect">
             <a:avLst/>
@@ -3949,13 +3967,13 @@
           <a:p>
             <a:pPr algn="l"/>
             <a:r>
-              <a:rPr lang="en-IN" sz="1300" dirty="0">
+              <a:rPr lang="en-IN" sz="1500" dirty="0">
                 <a:solidFill>
                   <a:srgbClr val="FFFFFF">
                     <a:alpha val="90000"/>
                   </a:srgbClr>
                 </a:solidFill>
-                <a:latin typeface="Segoe UI"/>
+                <a:latin typeface="Consolas" panose="020B0609020204030204" pitchFamily="49" charset="0"/>
               </a:rPr>
               <a:t>K N Anirudh</a:t>
             </a:r>
@@ -3963,24 +3981,13 @@
           <a:p>
             <a:pPr algn="l"/>
             <a:r>
-              <a:rPr lang="en-IN" sz="1300" b="0" i="0" dirty="0">
+              <a:rPr sz="1500" b="0" i="0" dirty="0">
                 <a:solidFill>
                   <a:srgbClr val="FFFFFF">
                     <a:alpha val="90000"/>
                   </a:srgbClr>
                 </a:solidFill>
-                <a:latin typeface="Segoe UI"/>
-              </a:rPr>
-              <a:t>(Backend, Frontend, ppt)</a:t>
-            </a:r>
-            <a:r>
-              <a:rPr sz="1300" b="0" i="0" dirty="0">
-                <a:solidFill>
-                  <a:srgbClr val="FFFFFF">
-                    <a:alpha val="90000"/>
-                  </a:srgbClr>
-                </a:solidFill>
-                <a:latin typeface="Segoe UI"/>
+                <a:latin typeface="Consolas" panose="020B0609020204030204" pitchFamily="49" charset="0"/>
               </a:rPr>
               <a:t> </a:t>
             </a:r>
@@ -4009,9 +4016,11 @@
           </a:bodyPr>
           <a:lstStyle/>
           <a:p>
-            <a:pPr algn="l"/>
-            <a:r>
-              <a:rPr lang="en-IN" sz="1200" b="1" i="0" spc="160" dirty="0">
+            <a:pPr marL="228600" indent="-228600">
+              <a:buAutoNum type="arabicPeriod"/>
+            </a:pPr>
+            <a:r>
+              <a:rPr lang="en-IN" sz="1200" b="1" spc="160" dirty="0">
                 <a:solidFill>
                   <a:schemeClr val="bg1">
                     <a:lumMod val="95000"/>
@@ -4019,13 +4028,10 @@
                 </a:solidFill>
                 <a:latin typeface="Consolas"/>
               </a:rPr>
-              <a:t>1.Devyansh ( Presentation)</a:t>
-            </a:r>
-          </a:p>
-          <a:p>
-            <a:pPr algn="l"/>
-            <a:r>
-              <a:rPr lang="en-IN" sz="1200" b="1" spc="160" dirty="0">
+              <a:t> </a:t>
+            </a:r>
+            <a:r>
+              <a:rPr lang="en-IN" sz="1200" b="1" spc="160" dirty="0" err="1">
                 <a:solidFill>
                   <a:schemeClr val="bg1">
                     <a:lumMod val="95000"/>
@@ -4033,13 +4039,10 @@
                 </a:solidFill>
                 <a:latin typeface="Consolas"/>
               </a:rPr>
-              <a:t>2. Akash (Presentation)</a:t>
-            </a:r>
-          </a:p>
-          <a:p>
-            <a:pPr algn="l"/>
-            <a:r>
-              <a:rPr lang="en-IN" sz="1200" b="1" i="0" spc="160" dirty="0">
+              <a:t>Daivaansh</a:t>
+            </a:r>
+            <a:r>
+              <a:rPr lang="en-IN" sz="1200" b="1" spc="160" dirty="0">
                 <a:solidFill>
                   <a:schemeClr val="bg1">
                     <a:lumMod val="95000"/>
@@ -4047,11 +4050,13 @@
                 </a:solidFill>
                 <a:latin typeface="Consolas"/>
               </a:rPr>
-              <a:t>3.Keshav (Analysis of bugs)</a:t>
-            </a:r>
-          </a:p>
-          <a:p>
-            <a:pPr algn="l"/>
+              <a:t> Chandok   </a:t>
+            </a:r>
+          </a:p>
+          <a:p>
+            <a:pPr marL="228600" indent="-228600">
+              <a:buAutoNum type="arabicPeriod"/>
+            </a:pPr>
             <a:r>
               <a:rPr lang="en-IN" sz="1200" b="1" spc="160" dirty="0">
                 <a:solidFill>
@@ -4061,13 +4066,15 @@
                 </a:solidFill>
                 <a:latin typeface="Consolas"/>
               </a:rPr>
-              <a:t>4. Vedant(Research)</a:t>
-            </a:r>
-          </a:p>
-          <a:p>
-            <a:pPr algn="l"/>
-            <a:r>
-              <a:rPr lang="en-IN" sz="1200" b="1" i="0" spc="160" dirty="0">
+              <a:t> Akash Sharma</a:t>
+            </a:r>
+          </a:p>
+          <a:p>
+            <a:pPr marL="228600" indent="-228600">
+              <a:buAutoNum type="arabicPeriod"/>
+            </a:pPr>
+            <a:r>
+              <a:rPr lang="en-IN" sz="1200" b="1" spc="160" dirty="0">
                 <a:solidFill>
                   <a:schemeClr val="bg1">
                     <a:lumMod val="95000"/>
@@ -4075,8 +4082,11 @@
                 </a:solidFill>
                 <a:latin typeface="Consolas"/>
               </a:rPr>
-              <a:t>5. Divya</a:t>
-            </a:r>
+              <a:t>Divya Shree N </a:t>
+            </a:r>
+          </a:p>
+          <a:p>
+            <a:pPr algn="l"/>
             <a:r>
               <a:rPr lang="en-IN" sz="1200" b="1" spc="160" dirty="0">
                 <a:solidFill>
@@ -4086,7 +4096,54 @@
                 </a:solidFill>
                 <a:latin typeface="Consolas"/>
               </a:rPr>
-              <a:t> Shree N (UI ,Planning, ppt) </a:t>
+              <a:t>4. </a:t>
+            </a:r>
+            <a:r>
+              <a:rPr lang="en-IN" sz="1200" b="1" i="0" spc="160" dirty="0">
+                <a:solidFill>
+                  <a:schemeClr val="bg1">
+                    <a:lumMod val="95000"/>
+                  </a:schemeClr>
+                </a:solidFill>
+                <a:latin typeface="Consolas"/>
+              </a:rPr>
+              <a:t>Keshav </a:t>
+            </a:r>
+          </a:p>
+          <a:p>
+            <a:pPr algn="l"/>
+            <a:r>
+              <a:rPr lang="en-IN" sz="1200" b="1" spc="160" dirty="0">
+                <a:solidFill>
+                  <a:schemeClr val="bg1">
+                    <a:lumMod val="95000"/>
+                  </a:schemeClr>
+                </a:solidFill>
+                <a:latin typeface="Consolas"/>
+              </a:rPr>
+              <a:t>5. Vedant</a:t>
+            </a:r>
+            <a:r>
+              <a:rPr lang="en-IN" sz="1200" b="1" i="0" spc="160" dirty="0">
+                <a:solidFill>
+                  <a:schemeClr val="bg1">
+                    <a:lumMod val="95000"/>
+                  </a:schemeClr>
+                </a:solidFill>
+                <a:latin typeface="Consolas"/>
+              </a:rPr>
+              <a:t> </a:t>
+            </a:r>
+            <a:r>
+              <a:rPr lang="en-IN" sz="1200" b="1" spc="160" dirty="0">
+                <a:solidFill>
+                  <a:schemeClr val="bg1">
+                    <a:lumMod val="95000"/>
+                  </a:schemeClr>
+                </a:solidFill>
+                <a:latin typeface="Consolas"/>
+              </a:rPr>
+              <a:t> </a:t>
             </a:r>
             <a:endParaRPr sz="1200" b="1" i="0" spc="160" dirty="0">
               <a:solidFill>
@@ -4459,7 +4516,7 @@
         <p:spPr>
           <a:xfrm>
             <a:off x="621792" y="685800"/>
-            <a:ext cx="10881360" cy="777240"/>
+            <a:ext cx="10881360" cy="553998"/>
           </a:xfrm>
           <a:prstGeom prst="rect">
             <a:avLst/>
@@ -4474,11 +4531,11 @@
           <a:p>
             <a:pPr algn="l"/>
             <a:r>
-              <a:rPr sz="3300" b="1" i="0">
+              <a:rPr sz="3600" b="1" i="0" dirty="0">
                 <a:solidFill>
                   <a:srgbClr val="FFFFFF"/>
                 </a:solidFill>
-                <a:latin typeface="Segoe UI"/>
+                <a:latin typeface="Poor Richard" panose="02080502050505020702" pitchFamily="18" charset="0"/>
               </a:rPr>
               <a:t>See it before the deadline does.</a:t>
             </a:r>
@@ -4535,8 +4592,8 @@
         </p:nvSpPr>
         <p:spPr>
           <a:xfrm>
-            <a:off x="640080" y="2011680"/>
-            <a:ext cx="5029200" cy="640080"/>
+            <a:off x="640080" y="1824228"/>
+            <a:ext cx="5029200" cy="727507"/>
           </a:xfrm>
           <a:prstGeom prst="rect">
             <a:avLst/>
@@ -4555,13 +4612,13 @@
               </a:lnSpc>
             </a:pPr>
             <a:r>
-              <a:rPr sz="1300" b="0" i="0">
+              <a:rPr sz="1400" b="0" i="0" dirty="0">
                 <a:solidFill>
                   <a:srgbClr val="FFFFFF">
                     <a:alpha val="70000"/>
                   </a:srgbClr>
                 </a:solidFill>
-                <a:latin typeface="Segoe UI"/>
+                <a:latin typeface="Consolas" panose="020B0609020204030204" pitchFamily="49" charset="0"/>
               </a:rPr>
               <a:t>Digital learning tools track content delivery — not follow-through. Institutions learn a student is behind only when the deadline already has.</a:t>
             </a:r>
@@ -6423,13 +6480,13 @@
   <p:clrMapOvr>
     <a:masterClrMapping/>
   </p:clrMapOvr>
-  <mc:AlternateContent xmlns:mc="http://schemas.openxmlformats.org/markup-compatibility/2006">
-    <mc:Choice xmlns:p14="http://schemas.microsoft.com/office/powerpoint/2010/main" Requires="p14">
+  <mc:AlternateContent xmlns:mc="http://schemas.openxmlformats.org/markup-compatibility/2006" xmlns:p14="http://schemas.microsoft.com/office/powerpoint/2010/main">
+    <mc:Choice Requires="p14">
       <p:transition spd="slow" p14:dur="3900">
         <p14:glitter pattern="hexagon"/>
       </p:transition>
     </mc:Choice>
-    <mc:Fallback>
+    <mc:Fallback xmlns="">
       <p:transition spd="slow">
         <p:fade/>
       </p:transition>
@@ -6463,7 +6520,7 @@
         </p:nvSpPr>
         <p:spPr>
           <a:xfrm>
-            <a:off x="-45720" y="-45720"/>
+            <a:off x="32004" y="-27432"/>
             <a:ext cx="12280392" cy="6949440"/>
           </a:xfrm>
           <a:prstGeom prst="rect">
@@ -8387,13 +8444,43 @@
           </a:p>
         </p:txBody>
       </p:sp>
+      <p:pic>
+        <p:nvPicPr>
+          <p:cNvPr id="48" name="Picture 47">
+            <a:extLst>
+              <a:ext uri="{FF2B5EF4-FFF2-40B4-BE49-F238E27FC236}">
+                <a16:creationId xmlns:a16="http://schemas.microsoft.com/office/drawing/2014/main" id="{7C06269A-7957-0170-807B-5C48C0700575}"/>
+              </a:ext>
+            </a:extLst>
+          </p:cNvPr>
+          <p:cNvPicPr>
+            <a:picLocks noChangeAspect="1"/>
+          </p:cNvPicPr>
+          <p:nvPr/>
+        </p:nvPicPr>
+        <p:blipFill>
+          <a:blip r:embed="rId3"/>
+          <a:stretch>
+            <a:fillRect/>
+          </a:stretch>
+        </p:blipFill>
+        <p:spPr>
+          <a:xfrm>
+            <a:off x="6094476" y="1339596"/>
+            <a:ext cx="5852160" cy="3204972"/>
+          </a:xfrm>
+          <a:prstGeom prst="rect">
+            <a:avLst/>
+          </a:prstGeom>
+        </p:spPr>
+      </p:pic>
     </p:spTree>
   </p:cSld>
   <p:clrMapOvr>
     <a:masterClrMapping/>
   </p:clrMapOvr>
-  <mc:AlternateContent xmlns:mc="http://schemas.openxmlformats.org/markup-compatibility/2006">
-    <mc:Choice xmlns:p14="http://schemas.microsoft.com/office/powerpoint/2010/main" Requires="p14">
+  <mc:AlternateContent xmlns:mc="http://schemas.openxmlformats.org/markup-compatibility/2006" xmlns:p14="http://schemas.microsoft.com/office/powerpoint/2010/main">
+    <mc:Choice Requires="p14">
       <p:transition spd="slow" p14:dur="4000">
         <p14:honeycomb/>
         <p:sndAc>
@@ -8403,12 +8490,12 @@
         </p:sndAc>
       </p:transition>
     </mc:Choice>
-    <mc:Fallback>
+    <mc:Fallback xmlns="">
       <p:transition spd="slow">
         <p:fade/>
         <p:sndAc>
           <p:stSnd>
-            <p:snd r:embed="rId2" name="whoosh.wav"/>
+            <p:snd r:embed="rId4" name="whoosh.wav"/>
           </p:stSnd>
         </p:sndAc>
       </p:transition>
@@ -10508,7 +10595,7 @@
           <a:lstStyle/>
           <a:p>
             <a:pPr algn="ctr"/>
-            <a:endParaRPr/>
+            <a:endParaRPr dirty="0"/>
           </a:p>
         </p:txBody>
       </p:sp>
@@ -10814,8 +10901,8 @@
         </p:nvSpPr>
         <p:spPr>
           <a:xfrm>
-            <a:off x="868680" y="2606040"/>
-            <a:ext cx="4754880" cy="822960"/>
+            <a:off x="868680" y="2532804"/>
+            <a:ext cx="4754880" cy="470065"/>
           </a:xfrm>
           <a:prstGeom prst="rect">
             <a:avLst/>
@@ -10834,16 +10921,45 @@
               </a:lnSpc>
             </a:pPr>
             <a:r>
-              <a:rPr sz="1350" b="0" i="0">
+              <a:rPr lang="en-IN" sz="1350" b="1" dirty="0">
                 <a:solidFill>
                   <a:srgbClr val="FFFFFF">
                     <a:alpha val="82000"/>
                   </a:srgbClr>
                 </a:solidFill>
-                <a:latin typeface="Segoe UI"/>
-              </a:rPr>
-              <a:t>Lecturer finds out a student is behind only when the final submission is already late.</a:t>
-            </a:r>
+                <a:latin typeface="Lucida Sans Unicode" panose="020B0602030504020204" pitchFamily="34" charset="0"/>
+                <a:cs typeface="Lucida Sans Unicode" panose="020B0602030504020204" pitchFamily="34" charset="0"/>
+              </a:rPr>
+              <a:t>The problem isn’t identifying struggling students .</a:t>
+            </a:r>
+          </a:p>
+          <a:p>
+            <a:pPr algn="l">
+              <a:lnSpc>
+                <a:spcPct val="115000"/>
+              </a:lnSpc>
+            </a:pPr>
+            <a:r>
+              <a:rPr lang="en-IN" sz="1350" b="1" i="0" dirty="0">
+                <a:solidFill>
+                  <a:srgbClr val="FFFFFF">
+                    <a:alpha val="82000"/>
+                  </a:srgbClr>
+                </a:solidFill>
+                <a:latin typeface="Lucida Sans Unicode" panose="020B0602030504020204" pitchFamily="34" charset="0"/>
+                <a:cs typeface="Lucida Sans Unicode" panose="020B0602030504020204" pitchFamily="34" charset="0"/>
+              </a:rPr>
+              <a:t>It’s identifying them early enough to help . </a:t>
+            </a:r>
+            <a:endParaRPr sz="1350" b="1" i="0" dirty="0">
+              <a:solidFill>
+                <a:srgbClr val="FFFFFF">
+                  <a:alpha val="82000"/>
+                </a:srgbClr>
+              </a:solidFill>
+              <a:latin typeface="Lucida Sans Unicode" panose="020B0602030504020204" pitchFamily="34" charset="0"/>
+              <a:cs typeface="Lucida Sans Unicode" panose="020B0602030504020204" pitchFamily="34" charset="0"/>
+            </a:endParaRPr>
           </a:p>
         </p:txBody>
       </p:sp>
@@ -11083,7 +11199,7 @@
         <p:spPr>
           <a:xfrm>
             <a:off x="6309360" y="2606040"/>
-            <a:ext cx="5029200" cy="548640"/>
+            <a:ext cx="5029200" cy="457048"/>
           </a:xfrm>
           <a:prstGeom prst="rect">
             <a:avLst/>
@@ -11102,11 +11218,12 @@
               </a:lnSpc>
             </a:pPr>
             <a:r>
-              <a:rPr sz="1350" b="1" i="0">
+              <a:rPr sz="1350" b="1" i="0" dirty="0">
                 <a:solidFill>
                   <a:srgbClr val="FFFFFF"/>
                 </a:solidFill>
-                <a:latin typeface="Segoe UI"/>
+                <a:latin typeface="Lucida Sans Unicode" panose="020B0602030504020204" pitchFamily="34" charset="0"/>
+                <a:cs typeface="Lucida Sans Unicode" panose="020B0602030504020204" pitchFamily="34" charset="0"/>
               </a:rPr>
               <a:t>Command Center flags the Testing checkpoint stalled at 43%.</a:t>
             </a:r>
@@ -12096,7 +12213,7 @@
         <p:spPr>
           <a:xfrm>
             <a:off x="1170432" y="1929384"/>
-            <a:ext cx="9966960" cy="594360"/>
+            <a:ext cx="9966960" cy="255904"/>
           </a:xfrm>
           <a:prstGeom prst="rect">
             <a:avLst/>
@@ -12115,15 +12232,40 @@
               </a:lnSpc>
             </a:pPr>
             <a:r>
-              <a:rPr sz="1200" b="0" i="0">
+              <a:rPr sz="1600" b="0" i="0" dirty="0">
                 <a:solidFill>
                   <a:srgbClr val="FFFFFF">
                     <a:alpha val="85000"/>
                   </a:srgbClr>
                 </a:solidFill>
-                <a:latin typeface="Segoe UI"/>
-              </a:rPr>
-              <a:t>National Education Policy 2020 — flexible, learner-centred, technology-enabled education</a:t>
+                <a:latin typeface="Consolas" panose="020B0609020204030204" pitchFamily="49" charset="0"/>
+                <a:cs typeface="Segoe UI" panose="020B0502040204020203" pitchFamily="34" charset="0"/>
+              </a:rPr>
+              <a:t>National Education Policy 2020 — flexible, learner-</a:t>
+            </a:r>
+            <a:r>
+              <a:rPr sz="1600" b="0" i="0" dirty="0" err="1">
+                <a:solidFill>
+                  <a:srgbClr val="FFFFFF">
+                    <a:alpha val="85000"/>
+                  </a:srgbClr>
+                </a:solidFill>
+                <a:latin typeface="Consolas" panose="020B0609020204030204" pitchFamily="49" charset="0"/>
+                <a:cs typeface="Segoe UI" panose="020B0502040204020203" pitchFamily="34" charset="0"/>
+              </a:rPr>
+              <a:t>centred</a:t>
+            </a:r>
+            <a:r>
+              <a:rPr sz="1600" b="0" i="0" dirty="0">
+                <a:solidFill>
+                  <a:srgbClr val="FFFFFF">
+                    <a:alpha val="85000"/>
+                  </a:srgbClr>
+                </a:solidFill>
+                <a:latin typeface="Consolas" panose="020B0609020204030204" pitchFamily="49" charset="0"/>
+                <a:cs typeface="Segoe UI" panose="020B0502040204020203" pitchFamily="34" charset="0"/>
+              </a:rPr>
+              <a:t>, technology-enabled education</a:t>
             </a:r>
           </a:p>
         </p:txBody>
@@ -12223,7 +12365,7 @@
         <p:spPr>
           <a:xfrm>
             <a:off x="1170432" y="2679191"/>
-            <a:ext cx="9966960" cy="594360"/>
+            <a:ext cx="9966960" cy="255904"/>
           </a:xfrm>
           <a:prstGeom prst="rect">
             <a:avLst/>
@@ -12242,13 +12384,13 @@
               </a:lnSpc>
             </a:pPr>
             <a:r>
-              <a:rPr sz="1200" b="0" i="0">
+              <a:rPr sz="1600" b="0" i="0" dirty="0">
                 <a:solidFill>
                   <a:srgbClr val="FFFFFF">
                     <a:alpha val="85000"/>
                   </a:srgbClr>
                 </a:solidFill>
-                <a:latin typeface="Segoe UI"/>
+                <a:latin typeface="Consolas" panose="020B0609020204030204" pitchFamily="49" charset="0"/>
               </a:rPr>
               <a:t>Learning-analytics / early-warning-system research on formative, in-progress assessment</a:t>
             </a:r>
@@ -12350,7 +12492,7 @@
         <p:spPr>
           <a:xfrm>
             <a:off x="1170432" y="3428999"/>
-            <a:ext cx="9966960" cy="594360"/>
+            <a:ext cx="9966960" cy="255904"/>
           </a:xfrm>
           <a:prstGeom prst="rect">
             <a:avLst/>
@@ -12369,13 +12511,13 @@
               </a:lnSpc>
             </a:pPr>
             <a:r>
-              <a:rPr sz="1200" b="0" i="0">
+              <a:rPr sz="1600" b="0" i="0" dirty="0">
                 <a:solidFill>
                   <a:srgbClr val="FFFFFF">
                     <a:alpha val="85000"/>
                   </a:srgbClr>
                 </a:solidFill>
-                <a:latin typeface="Segoe UI"/>
+                <a:latin typeface="Consolas" panose="020B0609020204030204" pitchFamily="49" charset="0"/>
               </a:rPr>
               <a:t>Gamification-in-education research on engagement effects of streaks &amp; leaderboards</a:t>
             </a:r>
@@ -12477,7 +12619,7 @@
         <p:spPr>
           <a:xfrm>
             <a:off x="1170432" y="4178807"/>
-            <a:ext cx="9966960" cy="390300"/>
+            <a:ext cx="9966960" cy="728854"/>
           </a:xfrm>
           <a:prstGeom prst="rect">
             <a:avLst/>
@@ -12496,15 +12638,26 @@
               </a:lnSpc>
             </a:pPr>
             <a:r>
-              <a:rPr sz="1200" b="0" i="0" dirty="0">
+              <a:rPr sz="1600" b="0" i="0" dirty="0">
                 <a:solidFill>
                   <a:srgbClr val="FFFFFF">
                     <a:alpha val="85000"/>
                   </a:srgbClr>
                 </a:solidFill>
+                <a:latin typeface="Consolas" panose="020B0609020204030204" pitchFamily="49" charset="0"/>
+              </a:rPr>
+              <a:t>Positioning: Classroom/Moodle track endpoints only; Duolingo-style apps gamify without institutional visibility — Avance sits in the gap</a:t>
+            </a:r>
+            <a:r>
+              <a:rPr sz="1200" b="0" i="0" dirty="0">
+                <a:solidFill>
+                  <a:srgbClr val="FFFFFF">
+                    <a:alpha val="85000"/>
+                  </a:srgbClr>
+                </a:solidFill>
                 <a:latin typeface="Segoe UI"/>
               </a:rPr>
-              <a:t>Positioning: Classroom/Moodle track endpoints only; Duolingo-style apps gamify without institutional visibility — Avance sits in the gap.</a:t>
+              <a:t>.</a:t>
             </a:r>
             <a:endParaRPr lang="en-IN" sz="1200" b="0" i="0" dirty="0">
               <a:solidFill>
@@ -12665,8 +12818,8 @@
         </p:nvSpPr>
         <p:spPr>
           <a:xfrm>
-            <a:off x="640080" y="5897880"/>
-            <a:ext cx="7315200" cy="457200"/>
+            <a:off x="640080" y="6041841"/>
+            <a:ext cx="7315200" cy="169277"/>
           </a:xfrm>
           <a:prstGeom prst="rect">
             <a:avLst/>
@@ -12679,15 +12832,68 @@
           </a:bodyPr>
           <a:lstStyle/>
           <a:p>
-            <a:pPr algn="l"/>
-            <a:r>
-              <a:rPr sz="1100" b="1" i="0">
+            <a:r>
+              <a:rPr sz="1100" b="1" i="0" dirty="0">
                 <a:solidFill>
                   <a:srgbClr val="8B85FF"/>
                 </a:solidFill>
                 <a:latin typeface="Consolas"/>
               </a:rPr>
-              <a:t>[ QR: live demo ]   Live demo: [your-deployment-url]   ·   Repo: [github link]</a:t>
+              <a:t>[ QR: live demo ]   Live demo: </a:t>
+            </a:r>
+            <a:r>
+              <a:rPr sz="1100" i="0" dirty="0">
+                <a:solidFill>
+                  <a:srgbClr val="8B85FF"/>
+                </a:solidFill>
+                <a:latin typeface="Consolas"/>
+              </a:rPr>
+              <a:t>[</a:t>
+            </a:r>
+            <a:r>
+              <a:rPr lang="en-IN" sz="1100" dirty="0">
+                <a:solidFill>
+                  <a:srgbClr val="8B85FF"/>
+                </a:solidFill>
+                <a:latin typeface="Consolas"/>
+              </a:rPr>
+              <a:t>https://avance-tufk.vercel.app/</a:t>
+            </a:r>
+            <a:r>
+              <a:rPr sz="1100" i="0" dirty="0">
+                <a:solidFill>
+                  <a:srgbClr val="8B85FF"/>
+                </a:solidFill>
+                <a:latin typeface="Consolas"/>
+              </a:rPr>
+              <a:t>]</a:t>
+            </a:r>
+            <a:r>
+              <a:rPr sz="1100" b="1" i="0" dirty="0">
+                <a:solidFill>
+                  <a:srgbClr val="8B85FF"/>
+                </a:solidFill>
+                <a:latin typeface="Consolas"/>
+              </a:rPr>
+              <a:t>   ·   Repo: [</a:t>
+            </a:r>
+            <a:r>
+              <a:rPr sz="1100" b="1" i="0" dirty="0" err="1">
+                <a:solidFill>
+                  <a:srgbClr val="8B85FF"/>
+                </a:solidFill>
+                <a:latin typeface="Consolas"/>
+              </a:rPr>
+              <a:t>github</a:t>
+            </a:r>
+            <a:r>
+              <a:rPr sz="1100" b="1" i="0" dirty="0">
+                <a:solidFill>
+                  <a:srgbClr val="8B85FF"/>
+                </a:solidFill>
+                <a:latin typeface="Consolas"/>
+              </a:rPr>
+              <a:t> link]</a:t>
             </a:r>
           </a:p>
         </p:txBody>

</xml_diff>